<commit_message>
adding notes for monday
</commit_message>
<xml_diff>
--- a/lessons/04_Meas_Assoc_Agree/images/04_Meas_Assoc_Agree_tables.pptx
+++ b/lessons/04_Meas_Assoc_Agree/images/04_Meas_Assoc_Agree_tables.pptx
@@ -6,9 +6,11 @@
   </p:sldMasterIdLst>
   <p:sldIdLst>
     <p:sldId id="256" r:id="rId2"/>
-    <p:sldId id="257" r:id="rId3"/>
-    <p:sldId id="258" r:id="rId4"/>
-    <p:sldId id="259" r:id="rId5"/>
+    <p:sldId id="260" r:id="rId3"/>
+    <p:sldId id="261" r:id="rId4"/>
+    <p:sldId id="257" r:id="rId5"/>
+    <p:sldId id="258" r:id="rId6"/>
+    <p:sldId id="259" r:id="rId7"/>
   </p:sldIdLst>
   <p:sldSz cx="12192000" cy="6858000"/>
   <p:notesSz cx="6858000" cy="9144000"/>
@@ -107,7 +109,110 @@
       </a:defRPr>
     </a:lvl9pPr>
   </p:defaultTextStyle>
+  <p:extLst>
+    <p:ext uri="{EFAFB233-063F-42B5-8137-9DF3F51BA10A}">
+      <p15:sldGuideLst xmlns:p15="http://schemas.microsoft.com/office/powerpoint/2012/main"/>
+    </p:ext>
+  </p:extLst>
 </p:presentation>
+</file>
+
+<file path=ppt/revisionInfo.xml><?xml version="1.0" encoding="utf-8"?>
+<p1510:revInfo xmlns:a="http://schemas.openxmlformats.org/drawingml/2006/main" xmlns:r="http://schemas.openxmlformats.org/officeDocument/2006/relationships" xmlns:p1510="http://schemas.microsoft.com/office/powerpoint/2015/10/main">
+  <p1510:revLst>
+    <p1510:client id="{DD2B96C5-FAE6-A74C-B575-339BD532F60F}" v="103" dt="2026-04-04T00:18:06.013"/>
+  </p1510:revLst>
+</p1510:revInfo>
+</file>
+
+<file path=ppt/changesInfos/changesInfo1.xml><?xml version="1.0" encoding="utf-8"?>
+<pc:chgInfo xmlns:a="http://schemas.openxmlformats.org/drawingml/2006/main" xmlns:r="http://schemas.openxmlformats.org/officeDocument/2006/relationships" xmlns:ac="http://schemas.microsoft.com/office/drawing/2013/main/command" xmlns:pc="http://schemas.microsoft.com/office/powerpoint/2013/main/command">
+  <pc:docChgLst>
+    <pc:chgData name="Nicky Wakim" userId="63a62853-8dd4-431b-8872-ecc2181a70d8" providerId="ADAL" clId="{88AEBF9D-5A98-5D2C-A60C-905B4F0F6AB9}"/>
+    <pc:docChg chg="undo custSel addSld modSld">
+      <pc:chgData name="Nicky Wakim" userId="63a62853-8dd4-431b-8872-ecc2181a70d8" providerId="ADAL" clId="{88AEBF9D-5A98-5D2C-A60C-905B4F0F6AB9}" dt="2026-04-04T00:18:06.013" v="561" actId="5736"/>
+      <pc:docMkLst>
+        <pc:docMk/>
+      </pc:docMkLst>
+      <pc:sldChg chg="addSp delSp modSp mod">
+        <pc:chgData name="Nicky Wakim" userId="63a62853-8dd4-431b-8872-ecc2181a70d8" providerId="ADAL" clId="{88AEBF9D-5A98-5D2C-A60C-905B4F0F6AB9}" dt="2026-04-03T23:24:33.937" v="184" actId="478"/>
+        <pc:sldMkLst>
+          <pc:docMk/>
+          <pc:sldMk cId="564690828" sldId="256"/>
+        </pc:sldMkLst>
+        <pc:graphicFrameChg chg="add mod modGraphic">
+          <ac:chgData name="Nicky Wakim" userId="63a62853-8dd4-431b-8872-ecc2181a70d8" providerId="ADAL" clId="{88AEBF9D-5A98-5D2C-A60C-905B4F0F6AB9}" dt="2026-04-03T23:20:36.568" v="122" actId="5736"/>
+          <ac:graphicFrameMkLst>
+            <pc:docMk/>
+            <pc:sldMk cId="564690828" sldId="256"/>
+            <ac:graphicFrameMk id="4" creationId="{1798D76C-DD12-8B7D-820A-955281A97164}"/>
+          </ac:graphicFrameMkLst>
+        </pc:graphicFrameChg>
+        <pc:graphicFrameChg chg="add mod modGraphic">
+          <ac:chgData name="Nicky Wakim" userId="63a62853-8dd4-431b-8872-ecc2181a70d8" providerId="ADAL" clId="{88AEBF9D-5A98-5D2C-A60C-905B4F0F6AB9}" dt="2026-04-03T23:23:51.165" v="182" actId="5736"/>
+          <ac:graphicFrameMkLst>
+            <pc:docMk/>
+            <pc:sldMk cId="564690828" sldId="256"/>
+            <ac:graphicFrameMk id="5" creationId="{5021357B-DE75-FDDB-C469-4B50ADC84EA6}"/>
+          </ac:graphicFrameMkLst>
+        </pc:graphicFrameChg>
+        <pc:graphicFrameChg chg="add del mod">
+          <ac:chgData name="Nicky Wakim" userId="63a62853-8dd4-431b-8872-ecc2181a70d8" providerId="ADAL" clId="{88AEBF9D-5A98-5D2C-A60C-905B4F0F6AB9}" dt="2026-04-03T23:24:33.937" v="184" actId="478"/>
+          <ac:graphicFrameMkLst>
+            <pc:docMk/>
+            <pc:sldMk cId="564690828" sldId="256"/>
+            <ac:graphicFrameMk id="6" creationId="{509A5D5A-0859-C0F6-9323-3207B63ABC98}"/>
+          </ac:graphicFrameMkLst>
+        </pc:graphicFrameChg>
+      </pc:sldChg>
+      <pc:sldChg chg="modSp mod">
+        <pc:chgData name="Nicky Wakim" userId="63a62853-8dd4-431b-8872-ecc2181a70d8" providerId="ADAL" clId="{88AEBF9D-5A98-5D2C-A60C-905B4F0F6AB9}" dt="2026-04-03T23:56:37.004" v="487" actId="5736"/>
+        <pc:sldMkLst>
+          <pc:docMk/>
+          <pc:sldMk cId="509836573" sldId="259"/>
+        </pc:sldMkLst>
+        <pc:graphicFrameChg chg="mod modGraphic">
+          <ac:chgData name="Nicky Wakim" userId="63a62853-8dd4-431b-8872-ecc2181a70d8" providerId="ADAL" clId="{88AEBF9D-5A98-5D2C-A60C-905B4F0F6AB9}" dt="2026-04-03T23:56:37.004" v="487" actId="5736"/>
+          <ac:graphicFrameMkLst>
+            <pc:docMk/>
+            <pc:sldMk cId="509836573" sldId="259"/>
+            <ac:graphicFrameMk id="4" creationId="{C04FFB06-05F3-A26A-A48B-6284D59107C2}"/>
+          </ac:graphicFrameMkLst>
+        </pc:graphicFrameChg>
+      </pc:sldChg>
+      <pc:sldChg chg="addSp modSp new mod">
+        <pc:chgData name="Nicky Wakim" userId="63a62853-8dd4-431b-8872-ecc2181a70d8" providerId="ADAL" clId="{88AEBF9D-5A98-5D2C-A60C-905B4F0F6AB9}" dt="2026-04-04T00:18:06.013" v="561" actId="5736"/>
+        <pc:sldMkLst>
+          <pc:docMk/>
+          <pc:sldMk cId="525226675" sldId="260"/>
+        </pc:sldMkLst>
+        <pc:graphicFrameChg chg="add mod modGraphic">
+          <ac:chgData name="Nicky Wakim" userId="63a62853-8dd4-431b-8872-ecc2181a70d8" providerId="ADAL" clId="{88AEBF9D-5A98-5D2C-A60C-905B4F0F6AB9}" dt="2026-04-04T00:17:48.772" v="560" actId="5736"/>
+          <ac:graphicFrameMkLst>
+            <pc:docMk/>
+            <pc:sldMk cId="525226675" sldId="260"/>
+            <ac:graphicFrameMk id="4" creationId="{40958B9C-9B03-0430-91B5-653402A0E93F}"/>
+          </ac:graphicFrameMkLst>
+        </pc:graphicFrameChg>
+        <pc:graphicFrameChg chg="add mod modGraphic">
+          <ac:chgData name="Nicky Wakim" userId="63a62853-8dd4-431b-8872-ecc2181a70d8" providerId="ADAL" clId="{88AEBF9D-5A98-5D2C-A60C-905B4F0F6AB9}" dt="2026-04-04T00:18:06.013" v="561" actId="5736"/>
+          <ac:graphicFrameMkLst>
+            <pc:docMk/>
+            <pc:sldMk cId="525226675" sldId="260"/>
+            <ac:graphicFrameMk id="5" creationId="{B40C426E-0364-9B42-4070-29C5F4B9C9D5}"/>
+          </ac:graphicFrameMkLst>
+        </pc:graphicFrameChg>
+      </pc:sldChg>
+      <pc:sldChg chg="new">
+        <pc:chgData name="Nicky Wakim" userId="63a62853-8dd4-431b-8872-ecc2181a70d8" providerId="ADAL" clId="{88AEBF9D-5A98-5D2C-A60C-905B4F0F6AB9}" dt="2026-04-04T00:09:58.018" v="488" actId="680"/>
+        <pc:sldMkLst>
+          <pc:docMk/>
+          <pc:sldMk cId="1026133207" sldId="261"/>
+        </pc:sldMkLst>
+      </pc:sldChg>
+    </pc:docChg>
+  </pc:docChgLst>
+</pc:chgInfo>
 </file>
 
 <file path=ppt/slideLayouts/slideLayout1.xml><?xml version="1.0" encoding="utf-8"?>
@@ -257,7 +362,7 @@
           <a:p>
             <a:fld id="{71D24951-EF53-404C-8342-5DB249438879}" type="datetimeFigureOut">
               <a:rPr lang="en-US" smtClean="0"/>
-              <a:t>4/9/24</a:t>
+              <a:t>4/3/26</a:t>
             </a:fld>
             <a:endParaRPr lang="en-US"/>
           </a:p>
@@ -455,7 +560,7 @@
           <a:p>
             <a:fld id="{71D24951-EF53-404C-8342-5DB249438879}" type="datetimeFigureOut">
               <a:rPr lang="en-US" smtClean="0"/>
-              <a:t>4/9/24</a:t>
+              <a:t>4/3/26</a:t>
             </a:fld>
             <a:endParaRPr lang="en-US"/>
           </a:p>
@@ -663,7 +768,7 @@
           <a:p>
             <a:fld id="{71D24951-EF53-404C-8342-5DB249438879}" type="datetimeFigureOut">
               <a:rPr lang="en-US" smtClean="0"/>
-              <a:t>4/9/24</a:t>
+              <a:t>4/3/26</a:t>
             </a:fld>
             <a:endParaRPr lang="en-US"/>
           </a:p>
@@ -861,7 +966,7 @@
           <a:p>
             <a:fld id="{71D24951-EF53-404C-8342-5DB249438879}" type="datetimeFigureOut">
               <a:rPr lang="en-US" smtClean="0"/>
-              <a:t>4/9/24</a:t>
+              <a:t>4/3/26</a:t>
             </a:fld>
             <a:endParaRPr lang="en-US"/>
           </a:p>
@@ -1136,7 +1241,7 @@
           <a:p>
             <a:fld id="{71D24951-EF53-404C-8342-5DB249438879}" type="datetimeFigureOut">
               <a:rPr lang="en-US" smtClean="0"/>
-              <a:t>4/9/24</a:t>
+              <a:t>4/3/26</a:t>
             </a:fld>
             <a:endParaRPr lang="en-US"/>
           </a:p>
@@ -1401,7 +1506,7 @@
           <a:p>
             <a:fld id="{71D24951-EF53-404C-8342-5DB249438879}" type="datetimeFigureOut">
               <a:rPr lang="en-US" smtClean="0"/>
-              <a:t>4/9/24</a:t>
+              <a:t>4/3/26</a:t>
             </a:fld>
             <a:endParaRPr lang="en-US"/>
           </a:p>
@@ -1813,7 +1918,7 @@
           <a:p>
             <a:fld id="{71D24951-EF53-404C-8342-5DB249438879}" type="datetimeFigureOut">
               <a:rPr lang="en-US" smtClean="0"/>
-              <a:t>4/9/24</a:t>
+              <a:t>4/3/26</a:t>
             </a:fld>
             <a:endParaRPr lang="en-US"/>
           </a:p>
@@ -1954,7 +2059,7 @@
           <a:p>
             <a:fld id="{71D24951-EF53-404C-8342-5DB249438879}" type="datetimeFigureOut">
               <a:rPr lang="en-US" smtClean="0"/>
-              <a:t>4/9/24</a:t>
+              <a:t>4/3/26</a:t>
             </a:fld>
             <a:endParaRPr lang="en-US"/>
           </a:p>
@@ -2067,7 +2172,7 @@
           <a:p>
             <a:fld id="{71D24951-EF53-404C-8342-5DB249438879}" type="datetimeFigureOut">
               <a:rPr lang="en-US" smtClean="0"/>
-              <a:t>4/9/24</a:t>
+              <a:t>4/3/26</a:t>
             </a:fld>
             <a:endParaRPr lang="en-US"/>
           </a:p>
@@ -2378,7 +2483,7 @@
           <a:p>
             <a:fld id="{71D24951-EF53-404C-8342-5DB249438879}" type="datetimeFigureOut">
               <a:rPr lang="en-US" smtClean="0"/>
-              <a:t>4/9/24</a:t>
+              <a:t>4/3/26</a:t>
             </a:fld>
             <a:endParaRPr lang="en-US"/>
           </a:p>
@@ -2666,7 +2771,7 @@
           <a:p>
             <a:fld id="{71D24951-EF53-404C-8342-5DB249438879}" type="datetimeFigureOut">
               <a:rPr lang="en-US" smtClean="0"/>
-              <a:t>4/9/24</a:t>
+              <a:t>4/3/26</a:t>
             </a:fld>
             <a:endParaRPr lang="en-US"/>
           </a:p>
@@ -2907,7 +3012,7 @@
           <a:p>
             <a:fld id="{71D24951-EF53-404C-8342-5DB249438879}" type="datetimeFigureOut">
               <a:rPr lang="en-US" smtClean="0"/>
-              <a:t>4/9/24</a:t>
+              <a:t>4/3/26</a:t>
             </a:fld>
             <a:endParaRPr lang="en-US"/>
           </a:p>
@@ -3345,7 +3450,7 @@
           <a:bodyPr/>
           <a:lstStyle/>
           <a:p>
-            <a:endParaRPr lang="en-US"/>
+            <a:endParaRPr lang="en-US" dirty="0"/>
           </a:p>
         </p:txBody>
       </p:sp>
@@ -3374,6 +3479,844 @@
           </a:p>
         </p:txBody>
       </p:sp>
+      <p:graphicFrame>
+        <p:nvGraphicFramePr>
+          <p:cNvPr id="4" name="Table 3">
+            <a:extLst>
+              <a:ext uri="{FF2B5EF4-FFF2-40B4-BE49-F238E27FC236}">
+                <a16:creationId xmlns:a16="http://schemas.microsoft.com/office/drawing/2014/main" id="{1798D76C-DD12-8B7D-820A-955281A97164}"/>
+              </a:ext>
+            </a:extLst>
+          </p:cNvPr>
+          <p:cNvGraphicFramePr>
+            <a:graphicFrameLocks noGrp="1"/>
+          </p:cNvGraphicFramePr>
+          <p:nvPr>
+            <p:extLst>
+              <p:ext uri="{D42A27DB-BD31-4B8C-83A1-F6EECF244321}">
+                <p14:modId xmlns:p14="http://schemas.microsoft.com/office/powerpoint/2010/main" val="81216830"/>
+              </p:ext>
+            </p:extLst>
+          </p:nvPr>
+        </p:nvGraphicFramePr>
+        <p:xfrm>
+          <a:off x="2282371" y="673100"/>
+          <a:ext cx="6175829" cy="1854200"/>
+        </p:xfrm>
+        <a:graphic>
+          <a:graphicData uri="http://schemas.openxmlformats.org/drawingml/2006/table">
+            <a:tbl>
+              <a:tblPr firstRow="1" bandRow="1">
+                <a:tableStyleId>{6E25E649-3F16-4E02-A733-19D2CDBF48F0}</a:tableStyleId>
+              </a:tblPr>
+              <a:tblGrid>
+                <a:gridCol w="1320800">
+                  <a:extLst>
+                    <a:ext uri="{9D8B030D-6E8A-4147-A177-3AD203B41FA5}">
+                      <a16:colId xmlns:a16="http://schemas.microsoft.com/office/drawing/2014/main" val="1119326435"/>
+                    </a:ext>
+                  </a:extLst>
+                </a:gridCol>
+                <a:gridCol w="2035629">
+                  <a:extLst>
+                    <a:ext uri="{9D8B030D-6E8A-4147-A177-3AD203B41FA5}">
+                      <a16:colId xmlns:a16="http://schemas.microsoft.com/office/drawing/2014/main" val="2226315093"/>
+                    </a:ext>
+                  </a:extLst>
+                </a:gridCol>
+                <a:gridCol w="1752600">
+                  <a:extLst>
+                    <a:ext uri="{9D8B030D-6E8A-4147-A177-3AD203B41FA5}">
+                      <a16:colId xmlns:a16="http://schemas.microsoft.com/office/drawing/2014/main" val="3974364938"/>
+                    </a:ext>
+                  </a:extLst>
+                </a:gridCol>
+                <a:gridCol w="1066800">
+                  <a:extLst>
+                    <a:ext uri="{9D8B030D-6E8A-4147-A177-3AD203B41FA5}">
+                      <a16:colId xmlns:a16="http://schemas.microsoft.com/office/drawing/2014/main" val="2987115445"/>
+                    </a:ext>
+                  </a:extLst>
+                </a:gridCol>
+              </a:tblGrid>
+              <a:tr h="370840">
+                <a:tc rowSpan="2">
+                  <a:txBody>
+                    <a:bodyPr/>
+                    <a:lstStyle/>
+                    <a:p>
+                      <a:pPr algn="ctr"/>
+                      <a:r>
+                        <a:rPr lang="en-US" dirty="0"/>
+                        <a:t>Explanatory Variable</a:t>
+                      </a:r>
+                    </a:p>
+                  </a:txBody>
+                  <a:tcPr anchor="ctr">
+                    <a:solidFill>
+                      <a:srgbClr val="5B9BD5"/>
+                    </a:solidFill>
+                  </a:tcPr>
+                </a:tc>
+                <a:tc gridSpan="2">
+                  <a:txBody>
+                    <a:bodyPr/>
+                    <a:lstStyle/>
+                    <a:p>
+                      <a:pPr algn="ctr"/>
+                      <a:r>
+                        <a:rPr lang="en-US" dirty="0"/>
+                        <a:t>Response Variable</a:t>
+                      </a:r>
+                    </a:p>
+                  </a:txBody>
+                  <a:tcPr anchor="ctr">
+                    <a:solidFill>
+                      <a:srgbClr val="5B9BD5"/>
+                    </a:solidFill>
+                  </a:tcPr>
+                </a:tc>
+                <a:tc hMerge="1">
+                  <a:txBody>
+                    <a:bodyPr/>
+                    <a:lstStyle/>
+                    <a:p>
+                      <a:endParaRPr lang="en-US" dirty="0"/>
+                    </a:p>
+                  </a:txBody>
+                  <a:tcPr/>
+                </a:tc>
+                <a:tc rowSpan="2">
+                  <a:txBody>
+                    <a:bodyPr/>
+                    <a:lstStyle/>
+                    <a:p>
+                      <a:pPr algn="ctr"/>
+                      <a:r>
+                        <a:rPr lang="en-US" dirty="0"/>
+                        <a:t>Total</a:t>
+                      </a:r>
+                    </a:p>
+                  </a:txBody>
+                  <a:tcPr anchor="ctr">
+                    <a:solidFill>
+                      <a:srgbClr val="5B9BD5"/>
+                    </a:solidFill>
+                  </a:tcPr>
+                </a:tc>
+                <a:extLst>
+                  <a:ext uri="{0D108BD9-81ED-4DB2-BD59-A6C34878D82A}">
+                    <a16:rowId xmlns:a16="http://schemas.microsoft.com/office/drawing/2014/main" val="4282440593"/>
+                  </a:ext>
+                </a:extLst>
+              </a:tr>
+              <a:tr h="370840">
+                <a:tc vMerge="1">
+                  <a:txBody>
+                    <a:bodyPr/>
+                    <a:lstStyle/>
+                    <a:p>
+                      <a:endParaRPr lang="en-US" dirty="0"/>
+                    </a:p>
+                  </a:txBody>
+                  <a:tcPr/>
+                </a:tc>
+                <a:tc>
+                  <a:txBody>
+                    <a:bodyPr/>
+                    <a:lstStyle/>
+                    <a:p>
+                      <a:pPr algn="ctr"/>
+                      <a:r>
+                        <a:rPr lang="en-US" dirty="0"/>
+                        <a:t>Failure/Control (0)</a:t>
+                      </a:r>
+                    </a:p>
+                  </a:txBody>
+                  <a:tcPr anchor="ctr"/>
+                </a:tc>
+                <a:tc>
+                  <a:txBody>
+                    <a:bodyPr/>
+                    <a:lstStyle/>
+                    <a:p>
+                      <a:pPr algn="ctr"/>
+                      <a:r>
+                        <a:rPr lang="en-US" dirty="0"/>
+                        <a:t>Success/Case (1)</a:t>
+                      </a:r>
+                    </a:p>
+                  </a:txBody>
+                  <a:tcPr anchor="ctr"/>
+                </a:tc>
+                <a:tc vMerge="1">
+                  <a:txBody>
+                    <a:bodyPr/>
+                    <a:lstStyle/>
+                    <a:p>
+                      <a:endParaRPr lang="en-US" dirty="0"/>
+                    </a:p>
+                  </a:txBody>
+                  <a:tcPr/>
+                </a:tc>
+                <a:extLst>
+                  <a:ext uri="{0D108BD9-81ED-4DB2-BD59-A6C34878D82A}">
+                    <a16:rowId xmlns:a16="http://schemas.microsoft.com/office/drawing/2014/main" val="2822264164"/>
+                  </a:ext>
+                </a:extLst>
+              </a:tr>
+              <a:tr h="370840">
+                <a:tc>
+                  <a:txBody>
+                    <a:bodyPr/>
+                    <a:lstStyle/>
+                    <a:p>
+                      <a:pPr algn="ctr"/>
+                      <a:r>
+                        <a:rPr lang="en-US" dirty="0"/>
+                        <a:t>Group 1</a:t>
+                      </a:r>
+                    </a:p>
+                  </a:txBody>
+                  <a:tcPr anchor="ctr"/>
+                </a:tc>
+                <a:tc>
+                  <a:txBody>
+                    <a:bodyPr/>
+                    <a:lstStyle/>
+                    <a:p>
+                      <a:pPr algn="ctr"/>
+                      <a:r>
+                        <a:rPr lang="en-US" dirty="0"/>
+                        <a:t>40 (n</a:t>
+                      </a:r>
+                      <a:r>
+                        <a:rPr lang="en-US" baseline="-25000" dirty="0"/>
+                        <a:t>10</a:t>
+                      </a:r>
+                      <a:r>
+                        <a:rPr lang="en-US" baseline="0" dirty="0"/>
+                        <a:t>)</a:t>
+                      </a:r>
+                      <a:endParaRPr lang="en-US" dirty="0"/>
+                    </a:p>
+                  </a:txBody>
+                  <a:tcPr anchor="ctr"/>
+                </a:tc>
+                <a:tc>
+                  <a:txBody>
+                    <a:bodyPr/>
+                    <a:lstStyle/>
+                    <a:p>
+                      <a:pPr algn="ctr"/>
+                      <a:r>
+                        <a:rPr lang="en-US" dirty="0"/>
+                        <a:t>40 (n</a:t>
+                      </a:r>
+                      <a:r>
+                        <a:rPr lang="en-US" baseline="-25000" dirty="0"/>
+                        <a:t>11</a:t>
+                      </a:r>
+                      <a:r>
+                        <a:rPr lang="en-US" baseline="0" dirty="0"/>
+                        <a:t>)</a:t>
+                      </a:r>
+                      <a:endParaRPr lang="en-US" dirty="0"/>
+                    </a:p>
+                  </a:txBody>
+                  <a:tcPr anchor="ctr"/>
+                </a:tc>
+                <a:tc>
+                  <a:txBody>
+                    <a:bodyPr/>
+                    <a:lstStyle/>
+                    <a:p>
+                      <a:pPr algn="ctr"/>
+                      <a:r>
+                        <a:rPr lang="en-US" dirty="0"/>
+                        <a:t>80 (n</a:t>
+                      </a:r>
+                      <a:r>
+                        <a:rPr lang="en-US" baseline="-25000" dirty="0"/>
+                        <a:t>1</a:t>
+                      </a:r>
+                      <a:r>
+                        <a:rPr lang="en-US" baseline="0" dirty="0"/>
+                        <a:t>)</a:t>
+                      </a:r>
+                      <a:endParaRPr lang="en-US" dirty="0"/>
+                    </a:p>
+                  </a:txBody>
+                  <a:tcPr anchor="ctr"/>
+                </a:tc>
+                <a:extLst>
+                  <a:ext uri="{0D108BD9-81ED-4DB2-BD59-A6C34878D82A}">
+                    <a16:rowId xmlns:a16="http://schemas.microsoft.com/office/drawing/2014/main" val="2810100620"/>
+                  </a:ext>
+                </a:extLst>
+              </a:tr>
+              <a:tr h="370840">
+                <a:tc>
+                  <a:txBody>
+                    <a:bodyPr/>
+                    <a:lstStyle/>
+                    <a:p>
+                      <a:pPr algn="ctr"/>
+                      <a:r>
+                        <a:rPr lang="en-US" dirty="0"/>
+                        <a:t>Group 2</a:t>
+                      </a:r>
+                    </a:p>
+                  </a:txBody>
+                  <a:tcPr anchor="ctr"/>
+                </a:tc>
+                <a:tc>
+                  <a:txBody>
+                    <a:bodyPr/>
+                    <a:lstStyle/>
+                    <a:p>
+                      <a:pPr algn="ctr"/>
+                      <a:r>
+                        <a:rPr lang="en-US" dirty="0"/>
+                        <a:t>160 (n</a:t>
+                      </a:r>
+                      <a:r>
+                        <a:rPr lang="en-US" baseline="-25000" dirty="0"/>
+                        <a:t>20</a:t>
+                      </a:r>
+                      <a:r>
+                        <a:rPr lang="en-US" baseline="0" dirty="0"/>
+                        <a:t>)</a:t>
+                      </a:r>
+                      <a:endParaRPr lang="en-US" dirty="0"/>
+                    </a:p>
+                  </a:txBody>
+                  <a:tcPr anchor="ctr"/>
+                </a:tc>
+                <a:tc>
+                  <a:txBody>
+                    <a:bodyPr/>
+                    <a:lstStyle/>
+                    <a:p>
+                      <a:pPr algn="ctr"/>
+                      <a:r>
+                        <a:rPr lang="en-US" dirty="0"/>
+                        <a:t>60 (n</a:t>
+                      </a:r>
+                      <a:r>
+                        <a:rPr lang="en-US" baseline="-25000" dirty="0"/>
+                        <a:t>21</a:t>
+                      </a:r>
+                      <a:r>
+                        <a:rPr lang="en-US" baseline="0" dirty="0"/>
+                        <a:t>)</a:t>
+                      </a:r>
+                      <a:endParaRPr lang="en-US" dirty="0"/>
+                    </a:p>
+                  </a:txBody>
+                  <a:tcPr anchor="ctr"/>
+                </a:tc>
+                <a:tc>
+                  <a:txBody>
+                    <a:bodyPr/>
+                    <a:lstStyle/>
+                    <a:p>
+                      <a:pPr algn="ctr"/>
+                      <a:r>
+                        <a:rPr lang="en-US" dirty="0"/>
+                        <a:t>220 (n</a:t>
+                      </a:r>
+                      <a:r>
+                        <a:rPr lang="en-US" baseline="-25000" dirty="0"/>
+                        <a:t>2</a:t>
+                      </a:r>
+                      <a:r>
+                        <a:rPr lang="en-US" baseline="0" dirty="0"/>
+                        <a:t>)</a:t>
+                      </a:r>
+                      <a:endParaRPr lang="en-US" dirty="0"/>
+                    </a:p>
+                  </a:txBody>
+                  <a:tcPr anchor="ctr"/>
+                </a:tc>
+                <a:extLst>
+                  <a:ext uri="{0D108BD9-81ED-4DB2-BD59-A6C34878D82A}">
+                    <a16:rowId xmlns:a16="http://schemas.microsoft.com/office/drawing/2014/main" val="501102760"/>
+                  </a:ext>
+                </a:extLst>
+              </a:tr>
+              <a:tr h="370840">
+                <a:tc>
+                  <a:txBody>
+                    <a:bodyPr/>
+                    <a:lstStyle/>
+                    <a:p>
+                      <a:pPr algn="ctr"/>
+                      <a:r>
+                        <a:rPr lang="en-US" dirty="0"/>
+                        <a:t>Total</a:t>
+                      </a:r>
+                    </a:p>
+                  </a:txBody>
+                  <a:tcPr anchor="ctr"/>
+                </a:tc>
+                <a:tc>
+                  <a:txBody>
+                    <a:bodyPr/>
+                    <a:lstStyle/>
+                    <a:p>
+                      <a:pPr algn="ctr"/>
+                      <a:r>
+                        <a:rPr lang="en-US" dirty="0"/>
+                        <a:t>200 (</a:t>
+                      </a:r>
+                      <a:r>
+                        <a:rPr lang="en-US" dirty="0" err="1"/>
+                        <a:t>n</a:t>
+                      </a:r>
+                      <a:r>
+                        <a:rPr lang="en-US" baseline="-25000" dirty="0" err="1"/>
+                        <a:t>F</a:t>
+                      </a:r>
+                      <a:r>
+                        <a:rPr lang="en-US" baseline="0" dirty="0"/>
+                        <a:t>)</a:t>
+                      </a:r>
+                      <a:endParaRPr lang="en-US" dirty="0"/>
+                    </a:p>
+                  </a:txBody>
+                  <a:tcPr anchor="ctr"/>
+                </a:tc>
+                <a:tc>
+                  <a:txBody>
+                    <a:bodyPr/>
+                    <a:lstStyle/>
+                    <a:p>
+                      <a:pPr algn="ctr"/>
+                      <a:r>
+                        <a:rPr lang="en-US" dirty="0"/>
+                        <a:t>100 (</a:t>
+                      </a:r>
+                      <a:r>
+                        <a:rPr lang="en-US" dirty="0" err="1"/>
+                        <a:t>n</a:t>
+                      </a:r>
+                      <a:r>
+                        <a:rPr lang="en-US" baseline="-25000" dirty="0" err="1"/>
+                        <a:t>S</a:t>
+                      </a:r>
+                      <a:r>
+                        <a:rPr lang="en-US" baseline="0" dirty="0"/>
+                        <a:t>)</a:t>
+                      </a:r>
+                      <a:endParaRPr lang="en-US" dirty="0"/>
+                    </a:p>
+                  </a:txBody>
+                  <a:tcPr anchor="ctr"/>
+                </a:tc>
+                <a:tc>
+                  <a:txBody>
+                    <a:bodyPr/>
+                    <a:lstStyle/>
+                    <a:p>
+                      <a:pPr algn="ctr"/>
+                      <a:r>
+                        <a:rPr lang="en-US" dirty="0"/>
+                        <a:t>300 (n)</a:t>
+                      </a:r>
+                    </a:p>
+                  </a:txBody>
+                  <a:tcPr anchor="ctr"/>
+                </a:tc>
+                <a:extLst>
+                  <a:ext uri="{0D108BD9-81ED-4DB2-BD59-A6C34878D82A}">
+                    <a16:rowId xmlns:a16="http://schemas.microsoft.com/office/drawing/2014/main" val="1751223167"/>
+                  </a:ext>
+                </a:extLst>
+              </a:tr>
+            </a:tbl>
+          </a:graphicData>
+        </a:graphic>
+      </p:graphicFrame>
+      <p:graphicFrame>
+        <p:nvGraphicFramePr>
+          <p:cNvPr id="5" name="Table 4">
+            <a:extLst>
+              <a:ext uri="{FF2B5EF4-FFF2-40B4-BE49-F238E27FC236}">
+                <a16:creationId xmlns:a16="http://schemas.microsoft.com/office/drawing/2014/main" id="{5021357B-DE75-FDDB-C469-4B50ADC84EA6}"/>
+              </a:ext>
+            </a:extLst>
+          </p:cNvPr>
+          <p:cNvGraphicFramePr>
+            <a:graphicFrameLocks noGrp="1"/>
+          </p:cNvGraphicFramePr>
+          <p:nvPr>
+            <p:extLst>
+              <p:ext uri="{D42A27DB-BD31-4B8C-83A1-F6EECF244321}">
+                <p14:modId xmlns:p14="http://schemas.microsoft.com/office/powerpoint/2010/main" val="2575899549"/>
+              </p:ext>
+            </p:extLst>
+          </p:nvPr>
+        </p:nvGraphicFramePr>
+        <p:xfrm>
+          <a:off x="2380343" y="3255962"/>
+          <a:ext cx="6186714" cy="1854200"/>
+        </p:xfrm>
+        <a:graphic>
+          <a:graphicData uri="http://schemas.openxmlformats.org/drawingml/2006/table">
+            <a:tbl>
+              <a:tblPr firstRow="1" bandRow="1">
+                <a:tableStyleId>{74C1A8A3-306A-4EB7-A6B1-4F7E0EB9C5D6}</a:tableStyleId>
+              </a:tblPr>
+              <a:tblGrid>
+                <a:gridCol w="1320800">
+                  <a:extLst>
+                    <a:ext uri="{9D8B030D-6E8A-4147-A177-3AD203B41FA5}">
+                      <a16:colId xmlns:a16="http://schemas.microsoft.com/office/drawing/2014/main" val="1119326435"/>
+                    </a:ext>
+                  </a:extLst>
+                </a:gridCol>
+                <a:gridCol w="2035629">
+                  <a:extLst>
+                    <a:ext uri="{9D8B030D-6E8A-4147-A177-3AD203B41FA5}">
+                      <a16:colId xmlns:a16="http://schemas.microsoft.com/office/drawing/2014/main" val="2226315093"/>
+                    </a:ext>
+                  </a:extLst>
+                </a:gridCol>
+                <a:gridCol w="1752600">
+                  <a:extLst>
+                    <a:ext uri="{9D8B030D-6E8A-4147-A177-3AD203B41FA5}">
+                      <a16:colId xmlns:a16="http://schemas.microsoft.com/office/drawing/2014/main" val="3974364938"/>
+                    </a:ext>
+                  </a:extLst>
+                </a:gridCol>
+                <a:gridCol w="1077685">
+                  <a:extLst>
+                    <a:ext uri="{9D8B030D-6E8A-4147-A177-3AD203B41FA5}">
+                      <a16:colId xmlns:a16="http://schemas.microsoft.com/office/drawing/2014/main" val="2987115445"/>
+                    </a:ext>
+                  </a:extLst>
+                </a:gridCol>
+              </a:tblGrid>
+              <a:tr h="370840">
+                <a:tc rowSpan="2">
+                  <a:txBody>
+                    <a:bodyPr/>
+                    <a:lstStyle/>
+                    <a:p>
+                      <a:pPr algn="ctr"/>
+                      <a:r>
+                        <a:rPr lang="en-US" dirty="0"/>
+                        <a:t>Explanatory Variable</a:t>
+                      </a:r>
+                    </a:p>
+                  </a:txBody>
+                  <a:tcPr anchor="ctr">
+                    <a:solidFill>
+                      <a:schemeClr val="accent6"/>
+                    </a:solidFill>
+                  </a:tcPr>
+                </a:tc>
+                <a:tc gridSpan="2">
+                  <a:txBody>
+                    <a:bodyPr/>
+                    <a:lstStyle/>
+                    <a:p>
+                      <a:pPr algn="ctr"/>
+                      <a:r>
+                        <a:rPr lang="en-US" dirty="0"/>
+                        <a:t>Response Variable</a:t>
+                      </a:r>
+                    </a:p>
+                  </a:txBody>
+                  <a:tcPr anchor="ctr">
+                    <a:solidFill>
+                      <a:schemeClr val="accent6"/>
+                    </a:solidFill>
+                  </a:tcPr>
+                </a:tc>
+                <a:tc hMerge="1">
+                  <a:txBody>
+                    <a:bodyPr/>
+                    <a:lstStyle/>
+                    <a:p>
+                      <a:endParaRPr lang="en-US" dirty="0"/>
+                    </a:p>
+                  </a:txBody>
+                  <a:tcPr/>
+                </a:tc>
+                <a:tc rowSpan="2">
+                  <a:txBody>
+                    <a:bodyPr/>
+                    <a:lstStyle/>
+                    <a:p>
+                      <a:pPr algn="ctr"/>
+                      <a:r>
+                        <a:rPr lang="en-US" dirty="0"/>
+                        <a:t>Total</a:t>
+                      </a:r>
+                    </a:p>
+                  </a:txBody>
+                  <a:tcPr anchor="ctr">
+                    <a:solidFill>
+                      <a:schemeClr val="accent6"/>
+                    </a:solidFill>
+                  </a:tcPr>
+                </a:tc>
+                <a:extLst>
+                  <a:ext uri="{0D108BD9-81ED-4DB2-BD59-A6C34878D82A}">
+                    <a16:rowId xmlns:a16="http://schemas.microsoft.com/office/drawing/2014/main" val="4282440593"/>
+                  </a:ext>
+                </a:extLst>
+              </a:tr>
+              <a:tr h="370840">
+                <a:tc vMerge="1">
+                  <a:txBody>
+                    <a:bodyPr/>
+                    <a:lstStyle/>
+                    <a:p>
+                      <a:endParaRPr lang="en-US" dirty="0"/>
+                    </a:p>
+                  </a:txBody>
+                  <a:tcPr/>
+                </a:tc>
+                <a:tc>
+                  <a:txBody>
+                    <a:bodyPr/>
+                    <a:lstStyle/>
+                    <a:p>
+                      <a:pPr algn="ctr"/>
+                      <a:r>
+                        <a:rPr lang="en-US" dirty="0"/>
+                        <a:t>Failure/Control (0)</a:t>
+                      </a:r>
+                    </a:p>
+                  </a:txBody>
+                  <a:tcPr anchor="ctr"/>
+                </a:tc>
+                <a:tc>
+                  <a:txBody>
+                    <a:bodyPr/>
+                    <a:lstStyle/>
+                    <a:p>
+                      <a:pPr algn="ctr"/>
+                      <a:r>
+                        <a:rPr lang="en-US" dirty="0"/>
+                        <a:t>Success/Case (1)</a:t>
+                      </a:r>
+                    </a:p>
+                  </a:txBody>
+                  <a:tcPr anchor="ctr"/>
+                </a:tc>
+                <a:tc vMerge="1">
+                  <a:txBody>
+                    <a:bodyPr/>
+                    <a:lstStyle/>
+                    <a:p>
+                      <a:endParaRPr lang="en-US" dirty="0"/>
+                    </a:p>
+                  </a:txBody>
+                  <a:tcPr/>
+                </a:tc>
+                <a:extLst>
+                  <a:ext uri="{0D108BD9-81ED-4DB2-BD59-A6C34878D82A}">
+                    <a16:rowId xmlns:a16="http://schemas.microsoft.com/office/drawing/2014/main" val="2822264164"/>
+                  </a:ext>
+                </a:extLst>
+              </a:tr>
+              <a:tr h="370840">
+                <a:tc>
+                  <a:txBody>
+                    <a:bodyPr/>
+                    <a:lstStyle/>
+                    <a:p>
+                      <a:pPr algn="ctr"/>
+                      <a:r>
+                        <a:rPr lang="en-US" dirty="0"/>
+                        <a:t>Group 1</a:t>
+                      </a:r>
+                    </a:p>
+                  </a:txBody>
+                  <a:tcPr anchor="ctr"/>
+                </a:tc>
+                <a:tc>
+                  <a:txBody>
+                    <a:bodyPr/>
+                    <a:lstStyle/>
+                    <a:p>
+                      <a:pPr algn="ctr"/>
+                      <a:r>
+                        <a:rPr lang="en-US" dirty="0"/>
+                        <a:t>4000</a:t>
+                      </a:r>
+                    </a:p>
+                  </a:txBody>
+                  <a:tcPr anchor="ctr"/>
+                </a:tc>
+                <a:tc>
+                  <a:txBody>
+                    <a:bodyPr/>
+                    <a:lstStyle/>
+                    <a:p>
+                      <a:pPr algn="ctr"/>
+                      <a:r>
+                        <a:rPr lang="en-US" dirty="0"/>
+                        <a:t>400</a:t>
+                      </a:r>
+                    </a:p>
+                  </a:txBody>
+                  <a:tcPr anchor="ctr"/>
+                </a:tc>
+                <a:tc>
+                  <a:txBody>
+                    <a:bodyPr/>
+                    <a:lstStyle/>
+                    <a:p>
+                      <a:pPr algn="ctr"/>
+                      <a:r>
+                        <a:rPr lang="en-US" dirty="0"/>
+                        <a:t>4400</a:t>
+                      </a:r>
+                    </a:p>
+                  </a:txBody>
+                  <a:tcPr anchor="ctr"/>
+                </a:tc>
+                <a:extLst>
+                  <a:ext uri="{0D108BD9-81ED-4DB2-BD59-A6C34878D82A}">
+                    <a16:rowId xmlns:a16="http://schemas.microsoft.com/office/drawing/2014/main" val="2810100620"/>
+                  </a:ext>
+                </a:extLst>
+              </a:tr>
+              <a:tr h="370840">
+                <a:tc>
+                  <a:txBody>
+                    <a:bodyPr/>
+                    <a:lstStyle/>
+                    <a:p>
+                      <a:pPr algn="ctr"/>
+                      <a:r>
+                        <a:rPr lang="en-US" dirty="0"/>
+                        <a:t>Group 2</a:t>
+                      </a:r>
+                    </a:p>
+                  </a:txBody>
+                  <a:tcPr anchor="ctr"/>
+                </a:tc>
+                <a:tc>
+                  <a:txBody>
+                    <a:bodyPr/>
+                    <a:lstStyle/>
+                    <a:p>
+                      <a:pPr algn="ctr"/>
+                      <a:r>
+                        <a:rPr lang="en-US" dirty="0"/>
+                        <a:t>1600</a:t>
+                      </a:r>
+                    </a:p>
+                  </a:txBody>
+                  <a:tcPr anchor="ctr"/>
+                </a:tc>
+                <a:tc>
+                  <a:txBody>
+                    <a:bodyPr/>
+                    <a:lstStyle/>
+                    <a:p>
+                      <a:pPr algn="ctr"/>
+                      <a:r>
+                        <a:rPr lang="en-US" dirty="0"/>
+                        <a:t>600</a:t>
+                      </a:r>
+                    </a:p>
+                  </a:txBody>
+                  <a:tcPr anchor="ctr"/>
+                </a:tc>
+                <a:tc>
+                  <a:txBody>
+                    <a:bodyPr/>
+                    <a:lstStyle/>
+                    <a:p>
+                      <a:pPr algn="ctr"/>
+                      <a:r>
+                        <a:rPr lang="en-US" dirty="0"/>
+                        <a:t>1660</a:t>
+                      </a:r>
+                    </a:p>
+                  </a:txBody>
+                  <a:tcPr anchor="ctr"/>
+                </a:tc>
+                <a:extLst>
+                  <a:ext uri="{0D108BD9-81ED-4DB2-BD59-A6C34878D82A}">
+                    <a16:rowId xmlns:a16="http://schemas.microsoft.com/office/drawing/2014/main" val="501102760"/>
+                  </a:ext>
+                </a:extLst>
+              </a:tr>
+              <a:tr h="370840">
+                <a:tc>
+                  <a:txBody>
+                    <a:bodyPr/>
+                    <a:lstStyle/>
+                    <a:p>
+                      <a:pPr algn="ctr"/>
+                      <a:r>
+                        <a:rPr lang="en-US" dirty="0"/>
+                        <a:t>Total</a:t>
+                      </a:r>
+                    </a:p>
+                  </a:txBody>
+                  <a:tcPr anchor="ctr"/>
+                </a:tc>
+                <a:tc>
+                  <a:txBody>
+                    <a:bodyPr/>
+                    <a:lstStyle/>
+                    <a:p>
+                      <a:pPr algn="ctr"/>
+                      <a:r>
+                        <a:rPr lang="en-US" dirty="0"/>
+                        <a:t>20000</a:t>
+                      </a:r>
+                    </a:p>
+                  </a:txBody>
+                  <a:tcPr anchor="ctr"/>
+                </a:tc>
+                <a:tc>
+                  <a:txBody>
+                    <a:bodyPr/>
+                    <a:lstStyle/>
+                    <a:p>
+                      <a:pPr algn="ctr"/>
+                      <a:r>
+                        <a:rPr lang="en-US" dirty="0"/>
+                        <a:t>1000</a:t>
+                      </a:r>
+                    </a:p>
+                  </a:txBody>
+                  <a:tcPr anchor="ctr"/>
+                </a:tc>
+                <a:tc>
+                  <a:txBody>
+                    <a:bodyPr/>
+                    <a:lstStyle/>
+                    <a:p>
+                      <a:pPr algn="ctr"/>
+                      <a:r>
+                        <a:rPr lang="en-US" dirty="0"/>
+                        <a:t>21000</a:t>
+                      </a:r>
+                    </a:p>
+                  </a:txBody>
+                  <a:tcPr anchor="ctr"/>
+                </a:tc>
+                <a:extLst>
+                  <a:ext uri="{0D108BD9-81ED-4DB2-BD59-A6C34878D82A}">
+                    <a16:rowId xmlns:a16="http://schemas.microsoft.com/office/drawing/2014/main" val="1751223167"/>
+                  </a:ext>
+                </a:extLst>
+              </a:tr>
+            </a:tbl>
+          </a:graphicData>
+        </a:graphic>
+      </p:graphicFrame>
     </p:spTree>
     <p:extLst>
       <p:ext uri="{BB962C8B-B14F-4D97-AF65-F5344CB8AC3E}">
@@ -3388,6 +4331,1078 @@
 </file>
 
 <file path=ppt/slides/slide2.xml><?xml version="1.0" encoding="utf-8"?>
+<p:sld xmlns:a="http://schemas.openxmlformats.org/drawingml/2006/main" xmlns:r="http://schemas.openxmlformats.org/officeDocument/2006/relationships" xmlns:p="http://schemas.openxmlformats.org/presentationml/2006/main">
+  <p:cSld>
+    <p:spTree>
+      <p:nvGrpSpPr>
+        <p:cNvPr id="1" name=""/>
+        <p:cNvGrpSpPr/>
+        <p:nvPr/>
+      </p:nvGrpSpPr>
+      <p:grpSpPr>
+        <a:xfrm>
+          <a:off x="0" y="0"/>
+          <a:ext cx="0" cy="0"/>
+          <a:chOff x="0" y="0"/>
+          <a:chExt cx="0" cy="0"/>
+        </a:xfrm>
+      </p:grpSpPr>
+      <p:sp>
+        <p:nvSpPr>
+          <p:cNvPr id="2" name="Title 1">
+            <a:extLst>
+              <a:ext uri="{FF2B5EF4-FFF2-40B4-BE49-F238E27FC236}">
+                <a16:creationId xmlns:a16="http://schemas.microsoft.com/office/drawing/2014/main" id="{6DB92F0A-8B0A-74C9-2302-B69608B42E4B}"/>
+              </a:ext>
+            </a:extLst>
+          </p:cNvPr>
+          <p:cNvSpPr>
+            <a:spLocks noGrp="1"/>
+          </p:cNvSpPr>
+          <p:nvPr>
+            <p:ph type="title"/>
+          </p:nvPr>
+        </p:nvSpPr>
+        <p:spPr/>
+        <p:txBody>
+          <a:bodyPr/>
+          <a:lstStyle/>
+          <a:p>
+            <a:endParaRPr lang="en-US"/>
+          </a:p>
+        </p:txBody>
+      </p:sp>
+      <p:sp>
+        <p:nvSpPr>
+          <p:cNvPr id="3" name="Content Placeholder 2">
+            <a:extLst>
+              <a:ext uri="{FF2B5EF4-FFF2-40B4-BE49-F238E27FC236}">
+                <a16:creationId xmlns:a16="http://schemas.microsoft.com/office/drawing/2014/main" id="{69188DA5-EF76-A96E-4730-FB389F54B042}"/>
+              </a:ext>
+            </a:extLst>
+          </p:cNvPr>
+          <p:cNvSpPr>
+            <a:spLocks noGrp="1"/>
+          </p:cNvSpPr>
+          <p:nvPr>
+            <p:ph idx="1"/>
+          </p:nvPr>
+        </p:nvSpPr>
+        <p:spPr/>
+        <p:txBody>
+          <a:bodyPr/>
+          <a:lstStyle/>
+          <a:p>
+            <a:endParaRPr lang="en-US" dirty="0"/>
+          </a:p>
+        </p:txBody>
+      </p:sp>
+      <p:graphicFrame>
+        <p:nvGraphicFramePr>
+          <p:cNvPr id="4" name="Table 3">
+            <a:extLst>
+              <a:ext uri="{FF2B5EF4-FFF2-40B4-BE49-F238E27FC236}">
+                <a16:creationId xmlns:a16="http://schemas.microsoft.com/office/drawing/2014/main" id="{40958B9C-9B03-0430-91B5-653402A0E93F}"/>
+              </a:ext>
+            </a:extLst>
+          </p:cNvPr>
+          <p:cNvGraphicFramePr>
+            <a:graphicFrameLocks noGrp="1"/>
+          </p:cNvGraphicFramePr>
+          <p:nvPr>
+            <p:extLst>
+              <p:ext uri="{D42A27DB-BD31-4B8C-83A1-F6EECF244321}">
+                <p14:modId xmlns:p14="http://schemas.microsoft.com/office/powerpoint/2010/main" val="2596624256"/>
+              </p:ext>
+            </p:extLst>
+          </p:nvPr>
+        </p:nvGraphicFramePr>
+        <p:xfrm>
+          <a:off x="2282370" y="673099"/>
+          <a:ext cx="6328230" cy="2011680"/>
+        </p:xfrm>
+        <a:graphic>
+          <a:graphicData uri="http://schemas.openxmlformats.org/drawingml/2006/table">
+            <a:tbl>
+              <a:tblPr firstRow="1" bandRow="1">
+                <a:tableStyleId>{6E25E649-3F16-4E02-A733-19D2CDBF48F0}</a:tableStyleId>
+              </a:tblPr>
+              <a:tblGrid>
+                <a:gridCol w="1114342">
+                  <a:extLst>
+                    <a:ext uri="{9D8B030D-6E8A-4147-A177-3AD203B41FA5}">
+                      <a16:colId xmlns:a16="http://schemas.microsoft.com/office/drawing/2014/main" val="1119326435"/>
+                    </a:ext>
+                  </a:extLst>
+                </a:gridCol>
+                <a:gridCol w="1717434">
+                  <a:extLst>
+                    <a:ext uri="{9D8B030D-6E8A-4147-A177-3AD203B41FA5}">
+                      <a16:colId xmlns:a16="http://schemas.microsoft.com/office/drawing/2014/main" val="2226315093"/>
+                    </a:ext>
+                  </a:extLst>
+                </a:gridCol>
+                <a:gridCol w="1478647">
+                  <a:extLst>
+                    <a:ext uri="{9D8B030D-6E8A-4147-A177-3AD203B41FA5}">
+                      <a16:colId xmlns:a16="http://schemas.microsoft.com/office/drawing/2014/main" val="3974364938"/>
+                    </a:ext>
+                  </a:extLst>
+                </a:gridCol>
+                <a:gridCol w="900046">
+                  <a:extLst>
+                    <a:ext uri="{9D8B030D-6E8A-4147-A177-3AD203B41FA5}">
+                      <a16:colId xmlns:a16="http://schemas.microsoft.com/office/drawing/2014/main" val="2987115445"/>
+                    </a:ext>
+                  </a:extLst>
+                </a:gridCol>
+                <a:gridCol w="1117761">
+                  <a:extLst>
+                    <a:ext uri="{9D8B030D-6E8A-4147-A177-3AD203B41FA5}">
+                      <a16:colId xmlns:a16="http://schemas.microsoft.com/office/drawing/2014/main" val="3415444892"/>
+                    </a:ext>
+                  </a:extLst>
+                </a:gridCol>
+              </a:tblGrid>
+              <a:tr h="354444">
+                <a:tc rowSpan="2">
+                  <a:txBody>
+                    <a:bodyPr/>
+                    <a:lstStyle/>
+                    <a:p>
+                      <a:pPr algn="ctr"/>
+                      <a:r>
+                        <a:rPr lang="en-US" dirty="0"/>
+                        <a:t>Explanatory Variable</a:t>
+                      </a:r>
+                    </a:p>
+                  </a:txBody>
+                  <a:tcPr anchor="ctr">
+                    <a:solidFill>
+                      <a:schemeClr val="accent1"/>
+                    </a:solidFill>
+                  </a:tcPr>
+                </a:tc>
+                <a:tc gridSpan="2">
+                  <a:txBody>
+                    <a:bodyPr/>
+                    <a:lstStyle/>
+                    <a:p>
+                      <a:pPr algn="ctr"/>
+                      <a:r>
+                        <a:rPr lang="en-US" dirty="0"/>
+                        <a:t>Response Variable</a:t>
+                      </a:r>
+                    </a:p>
+                  </a:txBody>
+                  <a:tcPr anchor="ctr">
+                    <a:solidFill>
+                      <a:schemeClr val="accent1"/>
+                    </a:solidFill>
+                  </a:tcPr>
+                </a:tc>
+                <a:tc hMerge="1">
+                  <a:txBody>
+                    <a:bodyPr/>
+                    <a:lstStyle/>
+                    <a:p>
+                      <a:endParaRPr lang="en-US" dirty="0"/>
+                    </a:p>
+                  </a:txBody>
+                  <a:tcPr/>
+                </a:tc>
+                <a:tc rowSpan="2">
+                  <a:txBody>
+                    <a:bodyPr/>
+                    <a:lstStyle/>
+                    <a:p>
+                      <a:pPr algn="ctr"/>
+                      <a:r>
+                        <a:rPr lang="en-US" dirty="0"/>
+                        <a:t>Total</a:t>
+                      </a:r>
+                    </a:p>
+                  </a:txBody>
+                  <a:tcPr anchor="ctr">
+                    <a:solidFill>
+                      <a:schemeClr val="accent1"/>
+                    </a:solidFill>
+                  </a:tcPr>
+                </a:tc>
+                <a:tc rowSpan="2">
+                  <a:txBody>
+                    <a:bodyPr/>
+                    <a:lstStyle/>
+                    <a:p>
+                      <a:pPr algn="ctr"/>
+                      <a:r>
+                        <a:rPr lang="en-US" dirty="0"/>
+                        <a:t>Risk</a:t>
+                      </a:r>
+                    </a:p>
+                  </a:txBody>
+                  <a:tcPr anchor="ctr">
+                    <a:solidFill>
+                      <a:schemeClr val="accent1"/>
+                    </a:solidFill>
+                  </a:tcPr>
+                </a:tc>
+                <a:extLst>
+                  <a:ext uri="{0D108BD9-81ED-4DB2-BD59-A6C34878D82A}">
+                    <a16:rowId xmlns:a16="http://schemas.microsoft.com/office/drawing/2014/main" val="4282440593"/>
+                  </a:ext>
+                </a:extLst>
+              </a:tr>
+              <a:tr h="467266">
+                <a:tc vMerge="1">
+                  <a:txBody>
+                    <a:bodyPr/>
+                    <a:lstStyle/>
+                    <a:p>
+                      <a:endParaRPr lang="en-US" dirty="0"/>
+                    </a:p>
+                  </a:txBody>
+                  <a:tcPr/>
+                </a:tc>
+                <a:tc>
+                  <a:txBody>
+                    <a:bodyPr/>
+                    <a:lstStyle/>
+                    <a:p>
+                      <a:pPr algn="ctr"/>
+                      <a:r>
+                        <a:rPr lang="en-US" dirty="0"/>
+                        <a:t>Failure (0)</a:t>
+                      </a:r>
+                    </a:p>
+                  </a:txBody>
+                  <a:tcPr anchor="ctr"/>
+                </a:tc>
+                <a:tc>
+                  <a:txBody>
+                    <a:bodyPr/>
+                    <a:lstStyle/>
+                    <a:p>
+                      <a:pPr algn="ctr"/>
+                      <a:r>
+                        <a:rPr lang="en-US" dirty="0"/>
+                        <a:t>Success (1)</a:t>
+                      </a:r>
+                    </a:p>
+                  </a:txBody>
+                  <a:tcPr anchor="ctr"/>
+                </a:tc>
+                <a:tc vMerge="1">
+                  <a:txBody>
+                    <a:bodyPr/>
+                    <a:lstStyle/>
+                    <a:p>
+                      <a:endParaRPr lang="en-US" dirty="0"/>
+                    </a:p>
+                  </a:txBody>
+                  <a:tcPr/>
+                </a:tc>
+                <a:tc vMerge="1">
+                  <a:txBody>
+                    <a:bodyPr/>
+                    <a:lstStyle/>
+                    <a:p>
+                      <a:endParaRPr lang="en-US"/>
+                    </a:p>
+                  </a:txBody>
+                  <a:tcPr/>
+                </a:tc>
+                <a:extLst>
+                  <a:ext uri="{0D108BD9-81ED-4DB2-BD59-A6C34878D82A}">
+                    <a16:rowId xmlns:a16="http://schemas.microsoft.com/office/drawing/2014/main" val="2822264164"/>
+                  </a:ext>
+                </a:extLst>
+              </a:tr>
+              <a:tr h="354444">
+                <a:tc>
+                  <a:txBody>
+                    <a:bodyPr/>
+                    <a:lstStyle/>
+                    <a:p>
+                      <a:pPr algn="ctr"/>
+                      <a:r>
+                        <a:rPr lang="en-US" dirty="0"/>
+                        <a:t>Group 1</a:t>
+                      </a:r>
+                    </a:p>
+                  </a:txBody>
+                  <a:tcPr anchor="ctr"/>
+                </a:tc>
+                <a:tc>
+                  <a:txBody>
+                    <a:bodyPr/>
+                    <a:lstStyle/>
+                    <a:p>
+                      <a:pPr algn="ctr"/>
+                      <a:r>
+                        <a:rPr lang="en-US" dirty="0"/>
+                        <a:t>9</a:t>
+                      </a:r>
+                    </a:p>
+                  </a:txBody>
+                  <a:tcPr anchor="ctr"/>
+                </a:tc>
+                <a:tc>
+                  <a:txBody>
+                    <a:bodyPr/>
+                    <a:lstStyle/>
+                    <a:p>
+                      <a:pPr algn="ctr"/>
+                      <a:r>
+                        <a:rPr lang="en-US" dirty="0"/>
+                        <a:t>9</a:t>
+                      </a:r>
+                    </a:p>
+                  </a:txBody>
+                  <a:tcPr anchor="ctr"/>
+                </a:tc>
+                <a:tc>
+                  <a:txBody>
+                    <a:bodyPr/>
+                    <a:lstStyle/>
+                    <a:p>
+                      <a:pPr algn="ctr"/>
+                      <a:r>
+                        <a:rPr lang="en-US" dirty="0"/>
+                        <a:t>18</a:t>
+                      </a:r>
+                    </a:p>
+                  </a:txBody>
+                  <a:tcPr anchor="ctr"/>
+                </a:tc>
+                <a:tc>
+                  <a:txBody>
+                    <a:bodyPr/>
+                    <a:lstStyle/>
+                    <a:p>
+                      <a:pPr algn="ctr"/>
+                      <a:r>
+                        <a:rPr lang="en-US" dirty="0"/>
+                        <a:t>0.5</a:t>
+                      </a:r>
+                    </a:p>
+                  </a:txBody>
+                  <a:tcPr anchor="ctr"/>
+                </a:tc>
+                <a:extLst>
+                  <a:ext uri="{0D108BD9-81ED-4DB2-BD59-A6C34878D82A}">
+                    <a16:rowId xmlns:a16="http://schemas.microsoft.com/office/drawing/2014/main" val="2810100620"/>
+                  </a:ext>
+                </a:extLst>
+              </a:tr>
+              <a:tr h="354444">
+                <a:tc>
+                  <a:txBody>
+                    <a:bodyPr/>
+                    <a:lstStyle/>
+                    <a:p>
+                      <a:pPr algn="ctr"/>
+                      <a:r>
+                        <a:rPr lang="en-US" dirty="0"/>
+                        <a:t>Group 2</a:t>
+                      </a:r>
+                    </a:p>
+                  </a:txBody>
+                  <a:tcPr anchor="ctr"/>
+                </a:tc>
+                <a:tc>
+                  <a:txBody>
+                    <a:bodyPr/>
+                    <a:lstStyle/>
+                    <a:p>
+                      <a:pPr algn="ctr"/>
+                      <a:r>
+                        <a:rPr lang="en-US" dirty="0"/>
+                        <a:t>981</a:t>
+                      </a:r>
+                    </a:p>
+                  </a:txBody>
+                  <a:tcPr anchor="ctr"/>
+                </a:tc>
+                <a:tc>
+                  <a:txBody>
+                    <a:bodyPr/>
+                    <a:lstStyle/>
+                    <a:p>
+                      <a:pPr algn="ctr"/>
+                      <a:r>
+                        <a:rPr lang="en-US" dirty="0"/>
+                        <a:t>1</a:t>
+                      </a:r>
+                    </a:p>
+                  </a:txBody>
+                  <a:tcPr anchor="ctr"/>
+                </a:tc>
+                <a:tc>
+                  <a:txBody>
+                    <a:bodyPr/>
+                    <a:lstStyle/>
+                    <a:p>
+                      <a:pPr algn="ctr"/>
+                      <a:r>
+                        <a:rPr lang="en-US" dirty="0"/>
+                        <a:t>982</a:t>
+                      </a:r>
+                    </a:p>
+                  </a:txBody>
+                  <a:tcPr anchor="ctr"/>
+                </a:tc>
+                <a:tc>
+                  <a:txBody>
+                    <a:bodyPr/>
+                    <a:lstStyle/>
+                    <a:p>
+                      <a:pPr algn="ctr"/>
+                      <a:r>
+                        <a:rPr lang="en-US" dirty="0"/>
+                        <a:t>0.00102</a:t>
+                      </a:r>
+                    </a:p>
+                  </a:txBody>
+                  <a:tcPr anchor="ctr"/>
+                </a:tc>
+                <a:extLst>
+                  <a:ext uri="{0D108BD9-81ED-4DB2-BD59-A6C34878D82A}">
+                    <a16:rowId xmlns:a16="http://schemas.microsoft.com/office/drawing/2014/main" val="501102760"/>
+                  </a:ext>
+                </a:extLst>
+              </a:tr>
+              <a:tr h="354444">
+                <a:tc>
+                  <a:txBody>
+                    <a:bodyPr/>
+                    <a:lstStyle/>
+                    <a:p>
+                      <a:pPr algn="ctr"/>
+                      <a:r>
+                        <a:rPr lang="en-US" dirty="0"/>
+                        <a:t>Total</a:t>
+                      </a:r>
+                    </a:p>
+                  </a:txBody>
+                  <a:tcPr anchor="ctr"/>
+                </a:tc>
+                <a:tc>
+                  <a:txBody>
+                    <a:bodyPr/>
+                    <a:lstStyle/>
+                    <a:p>
+                      <a:pPr algn="ctr"/>
+                      <a:r>
+                        <a:rPr lang="en-US" dirty="0"/>
+                        <a:t>990</a:t>
+                      </a:r>
+                    </a:p>
+                  </a:txBody>
+                  <a:tcPr anchor="ctr"/>
+                </a:tc>
+                <a:tc>
+                  <a:txBody>
+                    <a:bodyPr/>
+                    <a:lstStyle/>
+                    <a:p>
+                      <a:pPr algn="ctr"/>
+                      <a:r>
+                        <a:rPr lang="en-US" dirty="0"/>
+                        <a:t>10</a:t>
+                      </a:r>
+                    </a:p>
+                  </a:txBody>
+                  <a:tcPr anchor="ctr"/>
+                </a:tc>
+                <a:tc>
+                  <a:txBody>
+                    <a:bodyPr/>
+                    <a:lstStyle/>
+                    <a:p>
+                      <a:pPr algn="ctr"/>
+                      <a:r>
+                        <a:rPr lang="en-US" dirty="0"/>
+                        <a:t>1000</a:t>
+                      </a:r>
+                    </a:p>
+                  </a:txBody>
+                  <a:tcPr anchor="ctr"/>
+                </a:tc>
+                <a:tc>
+                  <a:txBody>
+                    <a:bodyPr/>
+                    <a:lstStyle/>
+                    <a:p>
+                      <a:pPr algn="ctr"/>
+                      <a:r>
+                        <a:rPr lang="en-US" dirty="0"/>
+                        <a:t>0.01010</a:t>
+                      </a:r>
+                    </a:p>
+                  </a:txBody>
+                  <a:tcPr anchor="ctr"/>
+                </a:tc>
+                <a:extLst>
+                  <a:ext uri="{0D108BD9-81ED-4DB2-BD59-A6C34878D82A}">
+                    <a16:rowId xmlns:a16="http://schemas.microsoft.com/office/drawing/2014/main" val="1751223167"/>
+                  </a:ext>
+                </a:extLst>
+              </a:tr>
+            </a:tbl>
+          </a:graphicData>
+        </a:graphic>
+      </p:graphicFrame>
+      <p:graphicFrame>
+        <p:nvGraphicFramePr>
+          <p:cNvPr id="5" name="Table 4">
+            <a:extLst>
+              <a:ext uri="{FF2B5EF4-FFF2-40B4-BE49-F238E27FC236}">
+                <a16:creationId xmlns:a16="http://schemas.microsoft.com/office/drawing/2014/main" id="{B40C426E-0364-9B42-4070-29C5F4B9C9D5}"/>
+              </a:ext>
+            </a:extLst>
+          </p:cNvPr>
+          <p:cNvGraphicFramePr>
+            <a:graphicFrameLocks noGrp="1"/>
+          </p:cNvGraphicFramePr>
+          <p:nvPr>
+            <p:extLst>
+              <p:ext uri="{D42A27DB-BD31-4B8C-83A1-F6EECF244321}">
+                <p14:modId xmlns:p14="http://schemas.microsoft.com/office/powerpoint/2010/main" val="897365041"/>
+              </p:ext>
+            </p:extLst>
+          </p:nvPr>
+        </p:nvGraphicFramePr>
+        <p:xfrm>
+          <a:off x="2282370" y="2995454"/>
+          <a:ext cx="6328230" cy="2011680"/>
+        </p:xfrm>
+        <a:graphic>
+          <a:graphicData uri="http://schemas.openxmlformats.org/drawingml/2006/table">
+            <a:tbl>
+              <a:tblPr firstRow="1" bandRow="1">
+                <a:tableStyleId>{6E25E649-3F16-4E02-A733-19D2CDBF48F0}</a:tableStyleId>
+              </a:tblPr>
+              <a:tblGrid>
+                <a:gridCol w="1114342">
+                  <a:extLst>
+                    <a:ext uri="{9D8B030D-6E8A-4147-A177-3AD203B41FA5}">
+                      <a16:colId xmlns:a16="http://schemas.microsoft.com/office/drawing/2014/main" val="1119326435"/>
+                    </a:ext>
+                  </a:extLst>
+                </a:gridCol>
+                <a:gridCol w="1717434">
+                  <a:extLst>
+                    <a:ext uri="{9D8B030D-6E8A-4147-A177-3AD203B41FA5}">
+                      <a16:colId xmlns:a16="http://schemas.microsoft.com/office/drawing/2014/main" val="2226315093"/>
+                    </a:ext>
+                  </a:extLst>
+                </a:gridCol>
+                <a:gridCol w="1478647">
+                  <a:extLst>
+                    <a:ext uri="{9D8B030D-6E8A-4147-A177-3AD203B41FA5}">
+                      <a16:colId xmlns:a16="http://schemas.microsoft.com/office/drawing/2014/main" val="3974364938"/>
+                    </a:ext>
+                  </a:extLst>
+                </a:gridCol>
+                <a:gridCol w="900046">
+                  <a:extLst>
+                    <a:ext uri="{9D8B030D-6E8A-4147-A177-3AD203B41FA5}">
+                      <a16:colId xmlns:a16="http://schemas.microsoft.com/office/drawing/2014/main" val="2987115445"/>
+                    </a:ext>
+                  </a:extLst>
+                </a:gridCol>
+                <a:gridCol w="1117761">
+                  <a:extLst>
+                    <a:ext uri="{9D8B030D-6E8A-4147-A177-3AD203B41FA5}">
+                      <a16:colId xmlns:a16="http://schemas.microsoft.com/office/drawing/2014/main" val="3415444892"/>
+                    </a:ext>
+                  </a:extLst>
+                </a:gridCol>
+              </a:tblGrid>
+              <a:tr h="354444">
+                <a:tc rowSpan="2">
+                  <a:txBody>
+                    <a:bodyPr/>
+                    <a:lstStyle/>
+                    <a:p>
+                      <a:pPr algn="ctr"/>
+                      <a:r>
+                        <a:rPr lang="en-US" dirty="0"/>
+                        <a:t>Explanatory Variable</a:t>
+                      </a:r>
+                    </a:p>
+                  </a:txBody>
+                  <a:tcPr anchor="ctr">
+                    <a:solidFill>
+                      <a:schemeClr val="accent4"/>
+                    </a:solidFill>
+                  </a:tcPr>
+                </a:tc>
+                <a:tc gridSpan="2">
+                  <a:txBody>
+                    <a:bodyPr/>
+                    <a:lstStyle/>
+                    <a:p>
+                      <a:pPr algn="ctr"/>
+                      <a:r>
+                        <a:rPr lang="en-US" dirty="0"/>
+                        <a:t>Response Variable</a:t>
+                      </a:r>
+                    </a:p>
+                  </a:txBody>
+                  <a:tcPr anchor="ctr">
+                    <a:solidFill>
+                      <a:schemeClr val="accent4"/>
+                    </a:solidFill>
+                  </a:tcPr>
+                </a:tc>
+                <a:tc hMerge="1">
+                  <a:txBody>
+                    <a:bodyPr/>
+                    <a:lstStyle/>
+                    <a:p>
+                      <a:endParaRPr lang="en-US" dirty="0"/>
+                    </a:p>
+                  </a:txBody>
+                  <a:tcPr/>
+                </a:tc>
+                <a:tc rowSpan="2">
+                  <a:txBody>
+                    <a:bodyPr/>
+                    <a:lstStyle/>
+                    <a:p>
+                      <a:pPr algn="ctr"/>
+                      <a:r>
+                        <a:rPr lang="en-US" dirty="0"/>
+                        <a:t>Total</a:t>
+                      </a:r>
+                    </a:p>
+                  </a:txBody>
+                  <a:tcPr anchor="ctr">
+                    <a:solidFill>
+                      <a:schemeClr val="accent4"/>
+                    </a:solidFill>
+                  </a:tcPr>
+                </a:tc>
+                <a:tc rowSpan="2">
+                  <a:txBody>
+                    <a:bodyPr/>
+                    <a:lstStyle/>
+                    <a:p>
+                      <a:pPr algn="ctr"/>
+                      <a:r>
+                        <a:rPr lang="en-US" dirty="0"/>
+                        <a:t>Risk</a:t>
+                      </a:r>
+                    </a:p>
+                  </a:txBody>
+                  <a:tcPr anchor="ctr">
+                    <a:solidFill>
+                      <a:schemeClr val="accent4"/>
+                    </a:solidFill>
+                  </a:tcPr>
+                </a:tc>
+                <a:extLst>
+                  <a:ext uri="{0D108BD9-81ED-4DB2-BD59-A6C34878D82A}">
+                    <a16:rowId xmlns:a16="http://schemas.microsoft.com/office/drawing/2014/main" val="4282440593"/>
+                  </a:ext>
+                </a:extLst>
+              </a:tr>
+              <a:tr h="467266">
+                <a:tc vMerge="1">
+                  <a:txBody>
+                    <a:bodyPr/>
+                    <a:lstStyle/>
+                    <a:p>
+                      <a:endParaRPr lang="en-US" dirty="0"/>
+                    </a:p>
+                  </a:txBody>
+                  <a:tcPr/>
+                </a:tc>
+                <a:tc>
+                  <a:txBody>
+                    <a:bodyPr/>
+                    <a:lstStyle/>
+                    <a:p>
+                      <a:pPr algn="ctr"/>
+                      <a:r>
+                        <a:rPr lang="en-US" dirty="0"/>
+                        <a:t>Failure (0)</a:t>
+                      </a:r>
+                    </a:p>
+                  </a:txBody>
+                  <a:tcPr anchor="ctr"/>
+                </a:tc>
+                <a:tc>
+                  <a:txBody>
+                    <a:bodyPr/>
+                    <a:lstStyle/>
+                    <a:p>
+                      <a:pPr algn="ctr"/>
+                      <a:r>
+                        <a:rPr lang="en-US" dirty="0"/>
+                        <a:t>Success (1)</a:t>
+                      </a:r>
+                    </a:p>
+                  </a:txBody>
+                  <a:tcPr anchor="ctr"/>
+                </a:tc>
+                <a:tc vMerge="1">
+                  <a:txBody>
+                    <a:bodyPr/>
+                    <a:lstStyle/>
+                    <a:p>
+                      <a:endParaRPr lang="en-US" dirty="0"/>
+                    </a:p>
+                  </a:txBody>
+                  <a:tcPr/>
+                </a:tc>
+                <a:tc vMerge="1">
+                  <a:txBody>
+                    <a:bodyPr/>
+                    <a:lstStyle/>
+                    <a:p>
+                      <a:endParaRPr lang="en-US"/>
+                    </a:p>
+                  </a:txBody>
+                  <a:tcPr/>
+                </a:tc>
+                <a:extLst>
+                  <a:ext uri="{0D108BD9-81ED-4DB2-BD59-A6C34878D82A}">
+                    <a16:rowId xmlns:a16="http://schemas.microsoft.com/office/drawing/2014/main" val="2822264164"/>
+                  </a:ext>
+                </a:extLst>
+              </a:tr>
+              <a:tr h="354444">
+                <a:tc>
+                  <a:txBody>
+                    <a:bodyPr/>
+                    <a:lstStyle/>
+                    <a:p>
+                      <a:pPr algn="ctr"/>
+                      <a:r>
+                        <a:rPr lang="en-US" dirty="0"/>
+                        <a:t>Group 1</a:t>
+                      </a:r>
+                    </a:p>
+                  </a:txBody>
+                  <a:tcPr anchor="ctr"/>
+                </a:tc>
+                <a:tc>
+                  <a:txBody>
+                    <a:bodyPr/>
+                    <a:lstStyle/>
+                    <a:p>
+                      <a:pPr algn="ctr"/>
+                      <a:r>
+                        <a:rPr lang="en-US" dirty="0"/>
+                        <a:t>100</a:t>
+                      </a:r>
+                    </a:p>
+                  </a:txBody>
+                  <a:tcPr anchor="ctr"/>
+                </a:tc>
+                <a:tc>
+                  <a:txBody>
+                    <a:bodyPr/>
+                    <a:lstStyle/>
+                    <a:p>
+                      <a:pPr algn="ctr"/>
+                      <a:r>
+                        <a:rPr lang="en-US" dirty="0"/>
+                        <a:t>9</a:t>
+                      </a:r>
+                    </a:p>
+                  </a:txBody>
+                  <a:tcPr anchor="ctr"/>
+                </a:tc>
+                <a:tc>
+                  <a:txBody>
+                    <a:bodyPr/>
+                    <a:lstStyle/>
+                    <a:p>
+                      <a:pPr algn="ctr"/>
+                      <a:r>
+                        <a:rPr lang="en-US" dirty="0"/>
+                        <a:t>109</a:t>
+                      </a:r>
+                    </a:p>
+                  </a:txBody>
+                  <a:tcPr anchor="ctr"/>
+                </a:tc>
+                <a:tc>
+                  <a:txBody>
+                    <a:bodyPr/>
+                    <a:lstStyle/>
+                    <a:p>
+                      <a:pPr algn="ctr"/>
+                      <a:r>
+                        <a:rPr lang="en-US" dirty="0"/>
+                        <a:t>0.0826</a:t>
+                      </a:r>
+                    </a:p>
+                  </a:txBody>
+                  <a:tcPr anchor="ctr"/>
+                </a:tc>
+                <a:extLst>
+                  <a:ext uri="{0D108BD9-81ED-4DB2-BD59-A6C34878D82A}">
+                    <a16:rowId xmlns:a16="http://schemas.microsoft.com/office/drawing/2014/main" val="2810100620"/>
+                  </a:ext>
+                </a:extLst>
+              </a:tr>
+              <a:tr h="354444">
+                <a:tc>
+                  <a:txBody>
+                    <a:bodyPr/>
+                    <a:lstStyle/>
+                    <a:p>
+                      <a:pPr algn="ctr"/>
+                      <a:r>
+                        <a:rPr lang="en-US" dirty="0"/>
+                        <a:t>Group 2</a:t>
+                      </a:r>
+                    </a:p>
+                  </a:txBody>
+                  <a:tcPr anchor="ctr"/>
+                </a:tc>
+                <a:tc>
+                  <a:txBody>
+                    <a:bodyPr/>
+                    <a:lstStyle/>
+                    <a:p>
+                      <a:pPr algn="ctr"/>
+                      <a:r>
+                        <a:rPr lang="en-US" dirty="0"/>
+                        <a:t>981</a:t>
+                      </a:r>
+                    </a:p>
+                  </a:txBody>
+                  <a:tcPr anchor="ctr"/>
+                </a:tc>
+                <a:tc>
+                  <a:txBody>
+                    <a:bodyPr/>
+                    <a:lstStyle/>
+                    <a:p>
+                      <a:pPr algn="ctr"/>
+                      <a:r>
+                        <a:rPr lang="en-US" dirty="0"/>
+                        <a:t>1</a:t>
+                      </a:r>
+                    </a:p>
+                  </a:txBody>
+                  <a:tcPr anchor="ctr"/>
+                </a:tc>
+                <a:tc>
+                  <a:txBody>
+                    <a:bodyPr/>
+                    <a:lstStyle/>
+                    <a:p>
+                      <a:pPr algn="ctr"/>
+                      <a:r>
+                        <a:rPr lang="en-US" dirty="0"/>
+                        <a:t>982</a:t>
+                      </a:r>
+                    </a:p>
+                  </a:txBody>
+                  <a:tcPr anchor="ctr"/>
+                </a:tc>
+                <a:tc>
+                  <a:txBody>
+                    <a:bodyPr/>
+                    <a:lstStyle/>
+                    <a:p>
+                      <a:pPr algn="ctr"/>
+                      <a:r>
+                        <a:rPr lang="en-US" dirty="0"/>
+                        <a:t>0.00102</a:t>
+                      </a:r>
+                    </a:p>
+                  </a:txBody>
+                  <a:tcPr anchor="ctr"/>
+                </a:tc>
+                <a:extLst>
+                  <a:ext uri="{0D108BD9-81ED-4DB2-BD59-A6C34878D82A}">
+                    <a16:rowId xmlns:a16="http://schemas.microsoft.com/office/drawing/2014/main" val="501102760"/>
+                  </a:ext>
+                </a:extLst>
+              </a:tr>
+              <a:tr h="354444">
+                <a:tc>
+                  <a:txBody>
+                    <a:bodyPr/>
+                    <a:lstStyle/>
+                    <a:p>
+                      <a:pPr algn="ctr"/>
+                      <a:r>
+                        <a:rPr lang="en-US" dirty="0"/>
+                        <a:t>Total</a:t>
+                      </a:r>
+                    </a:p>
+                  </a:txBody>
+                  <a:tcPr anchor="ctr"/>
+                </a:tc>
+                <a:tc>
+                  <a:txBody>
+                    <a:bodyPr/>
+                    <a:lstStyle/>
+                    <a:p>
+                      <a:pPr algn="ctr"/>
+                      <a:r>
+                        <a:rPr lang="en-US" dirty="0"/>
+                        <a:t>1081</a:t>
+                      </a:r>
+                    </a:p>
+                  </a:txBody>
+                  <a:tcPr anchor="ctr"/>
+                </a:tc>
+                <a:tc>
+                  <a:txBody>
+                    <a:bodyPr/>
+                    <a:lstStyle/>
+                    <a:p>
+                      <a:pPr algn="ctr"/>
+                      <a:r>
+                        <a:rPr lang="en-US" dirty="0"/>
+                        <a:t>10</a:t>
+                      </a:r>
+                    </a:p>
+                  </a:txBody>
+                  <a:tcPr anchor="ctr"/>
+                </a:tc>
+                <a:tc>
+                  <a:txBody>
+                    <a:bodyPr/>
+                    <a:lstStyle/>
+                    <a:p>
+                      <a:pPr algn="ctr"/>
+                      <a:r>
+                        <a:rPr lang="en-US" dirty="0"/>
+                        <a:t>1091</a:t>
+                      </a:r>
+                    </a:p>
+                  </a:txBody>
+                  <a:tcPr anchor="ctr"/>
+                </a:tc>
+                <a:tc>
+                  <a:txBody>
+                    <a:bodyPr/>
+                    <a:lstStyle/>
+                    <a:p>
+                      <a:pPr algn="ctr"/>
+                      <a:r>
+                        <a:rPr lang="en-US" dirty="0"/>
+                        <a:t>0.00925</a:t>
+                      </a:r>
+                    </a:p>
+                  </a:txBody>
+                  <a:tcPr anchor="ctr"/>
+                </a:tc>
+                <a:extLst>
+                  <a:ext uri="{0D108BD9-81ED-4DB2-BD59-A6C34878D82A}">
+                    <a16:rowId xmlns:a16="http://schemas.microsoft.com/office/drawing/2014/main" val="1751223167"/>
+                  </a:ext>
+                </a:extLst>
+              </a:tr>
+            </a:tbl>
+          </a:graphicData>
+        </a:graphic>
+      </p:graphicFrame>
+    </p:spTree>
+    <p:extLst>
+      <p:ext uri="{BB962C8B-B14F-4D97-AF65-F5344CB8AC3E}">
+        <p14:creationId xmlns:p14="http://schemas.microsoft.com/office/powerpoint/2010/main" val="525226675"/>
+      </p:ext>
+    </p:extLst>
+  </p:cSld>
+  <p:clrMapOvr>
+    <a:masterClrMapping/>
+  </p:clrMapOvr>
+</p:sld>
+</file>
+
+<file path=ppt/slides/slide3.xml><?xml version="1.0" encoding="utf-8"?>
+<p:sld xmlns:a="http://schemas.openxmlformats.org/drawingml/2006/main" xmlns:r="http://schemas.openxmlformats.org/officeDocument/2006/relationships" xmlns:p="http://schemas.openxmlformats.org/presentationml/2006/main">
+  <p:cSld>
+    <p:spTree>
+      <p:nvGrpSpPr>
+        <p:cNvPr id="1" name=""/>
+        <p:cNvGrpSpPr/>
+        <p:nvPr/>
+      </p:nvGrpSpPr>
+      <p:grpSpPr>
+        <a:xfrm>
+          <a:off x="0" y="0"/>
+          <a:ext cx="0" cy="0"/>
+          <a:chOff x="0" y="0"/>
+          <a:chExt cx="0" cy="0"/>
+        </a:xfrm>
+      </p:grpSpPr>
+      <p:sp>
+        <p:nvSpPr>
+          <p:cNvPr id="2" name="Title 1">
+            <a:extLst>
+              <a:ext uri="{FF2B5EF4-FFF2-40B4-BE49-F238E27FC236}">
+                <a16:creationId xmlns:a16="http://schemas.microsoft.com/office/drawing/2014/main" id="{23F1975D-B403-401B-9903-B07203A06059}"/>
+              </a:ext>
+            </a:extLst>
+          </p:cNvPr>
+          <p:cNvSpPr>
+            <a:spLocks noGrp="1"/>
+          </p:cNvSpPr>
+          <p:nvPr>
+            <p:ph type="title"/>
+          </p:nvPr>
+        </p:nvSpPr>
+        <p:spPr/>
+        <p:txBody>
+          <a:bodyPr/>
+          <a:lstStyle/>
+          <a:p>
+            <a:endParaRPr lang="en-US"/>
+          </a:p>
+        </p:txBody>
+      </p:sp>
+      <p:sp>
+        <p:nvSpPr>
+          <p:cNvPr id="3" name="Content Placeholder 2">
+            <a:extLst>
+              <a:ext uri="{FF2B5EF4-FFF2-40B4-BE49-F238E27FC236}">
+                <a16:creationId xmlns:a16="http://schemas.microsoft.com/office/drawing/2014/main" id="{9CC943BF-FA56-9F0E-1507-D340A8DC9EAC}"/>
+              </a:ext>
+            </a:extLst>
+          </p:cNvPr>
+          <p:cNvSpPr>
+            <a:spLocks noGrp="1"/>
+          </p:cNvSpPr>
+          <p:nvPr>
+            <p:ph idx="1"/>
+          </p:nvPr>
+        </p:nvSpPr>
+        <p:spPr/>
+        <p:txBody>
+          <a:bodyPr/>
+          <a:lstStyle/>
+          <a:p>
+            <a:endParaRPr lang="en-US"/>
+          </a:p>
+        </p:txBody>
+      </p:sp>
+    </p:spTree>
+    <p:extLst>
+      <p:ext uri="{BB962C8B-B14F-4D97-AF65-F5344CB8AC3E}">
+        <p14:creationId xmlns:p14="http://schemas.microsoft.com/office/powerpoint/2010/main" val="1026133207"/>
+      </p:ext>
+    </p:extLst>
+  </p:cSld>
+  <p:clrMapOvr>
+    <a:masterClrMapping/>
+  </p:clrMapOvr>
+</p:sld>
+</file>
+
+<file path=ppt/slides/slide4.xml><?xml version="1.0" encoding="utf-8"?>
 <p:sld xmlns:a="http://schemas.openxmlformats.org/drawingml/2006/main" xmlns:r="http://schemas.openxmlformats.org/officeDocument/2006/relationships" xmlns:p="http://schemas.openxmlformats.org/presentationml/2006/main">
   <p:cSld>
     <p:spTree>
@@ -3890,7 +5905,7 @@
 </p:sld>
 </file>
 
-<file path=ppt/slides/slide3.xml><?xml version="1.0" encoding="utf-8"?>
+<file path=ppt/slides/slide5.xml><?xml version="1.0" encoding="utf-8"?>
 <p:sld xmlns:a="http://schemas.openxmlformats.org/drawingml/2006/main" xmlns:r="http://schemas.openxmlformats.org/officeDocument/2006/relationships" xmlns:p="http://schemas.openxmlformats.org/presentationml/2006/main">
   <p:cSld>
     <p:spTree>
@@ -3957,8 +5972,8 @@
           </a:p>
         </p:txBody>
       </p:sp>
-      <mc:AlternateContent xmlns:mc="http://schemas.openxmlformats.org/markup-compatibility/2006">
-        <mc:Choice xmlns:a14="http://schemas.microsoft.com/office/drawing/2010/main" Requires="a14">
+      <mc:AlternateContent xmlns:mc="http://schemas.openxmlformats.org/markup-compatibility/2006" xmlns:a14="http://schemas.microsoft.com/office/drawing/2010/main">
+        <mc:Choice Requires="a14">
           <p:graphicFrame>
             <p:nvGraphicFramePr>
               <p:cNvPr id="4" name="Table 8">
@@ -4434,7 +6449,7 @@
             </a:graphic>
           </p:graphicFrame>
         </mc:Choice>
-        <mc:Fallback>
+        <mc:Fallback xmlns="">
           <p:graphicFrame>
             <p:nvGraphicFramePr>
               <p:cNvPr id="4" name="Table 8">
@@ -4848,7 +6863,7 @@
 </p:sld>
 </file>
 
-<file path=ppt/slides/slide4.xml><?xml version="1.0" encoding="utf-8"?>
+<file path=ppt/slides/slide6.xml><?xml version="1.0" encoding="utf-8"?>
 <p:sld xmlns:a="http://schemas.openxmlformats.org/drawingml/2006/main" xmlns:r="http://schemas.openxmlformats.org/officeDocument/2006/relationships" xmlns:p="http://schemas.openxmlformats.org/presentationml/2006/main">
   <p:cSld>
     <p:spTree>
@@ -4930,45 +6945,67 @@
           <p:nvPr>
             <p:extLst>
               <p:ext uri="{D42A27DB-BD31-4B8C-83A1-F6EECF244321}">
-                <p14:modId xmlns:p14="http://schemas.microsoft.com/office/powerpoint/2010/main" val="2561104448"/>
+                <p14:modId xmlns:p14="http://schemas.microsoft.com/office/powerpoint/2010/main" val="3571074539"/>
               </p:ext>
             </p:extLst>
           </p:nvPr>
         </p:nvGraphicFramePr>
         <p:xfrm>
           <a:off x="0" y="486346"/>
-          <a:ext cx="11843657" cy="5573967"/>
+          <a:ext cx="11317228" cy="5390388"/>
         </p:xfrm>
         <a:graphic>
           <a:graphicData uri="http://schemas.openxmlformats.org/drawingml/2006/table">
             <a:tbl>
               <a:tblPr firstRow="1" bandRow="1">
-                <a:tableStyleId>{7DF18680-E054-41AD-8BC1-D1AEF772440D}</a:tableStyleId>
+                <a:tableStyleId>{EB9631B5-78F2-41C9-869B-9F39066F8104}</a:tableStyleId>
               </a:tblPr>
               <a:tblGrid>
-                <a:gridCol w="2808514">
+                <a:gridCol w="1920240">
                   <a:extLst>
                     <a:ext uri="{9D8B030D-6E8A-4147-A177-3AD203B41FA5}">
                       <a16:colId xmlns:a16="http://schemas.microsoft.com/office/drawing/2014/main" val="1435345681"/>
                     </a:ext>
                   </a:extLst>
                 </a:gridCol>
-                <a:gridCol w="9035143">
+                <a:gridCol w="5830828">
                   <a:extLst>
                     <a:ext uri="{9D8B030D-6E8A-4147-A177-3AD203B41FA5}">
                       <a16:colId xmlns:a16="http://schemas.microsoft.com/office/drawing/2014/main" val="3701284272"/>
                     </a:ext>
                   </a:extLst>
                 </a:gridCol>
+                <a:gridCol w="1188720">
+                  <a:extLst>
+                    <a:ext uri="{9D8B030D-6E8A-4147-A177-3AD203B41FA5}">
+                      <a16:colId xmlns:a16="http://schemas.microsoft.com/office/drawing/2014/main" val="749139193"/>
+                    </a:ext>
+                  </a:extLst>
+                </a:gridCol>
+                <a:gridCol w="1188720">
+                  <a:extLst>
+                    <a:ext uri="{9D8B030D-6E8A-4147-A177-3AD203B41FA5}">
+                      <a16:colId xmlns:a16="http://schemas.microsoft.com/office/drawing/2014/main" val="1474706980"/>
+                    </a:ext>
+                  </a:extLst>
+                </a:gridCol>
+                <a:gridCol w="1188720">
+                  <a:extLst>
+                    <a:ext uri="{9D8B030D-6E8A-4147-A177-3AD203B41FA5}">
+                      <a16:colId xmlns:a16="http://schemas.microsoft.com/office/drawing/2014/main" val="3897955706"/>
+                    </a:ext>
+                  </a:extLst>
+                </a:gridCol>
               </a:tblGrid>
-              <a:tr h="370840">
-                <a:tc>
-                  <a:txBody>
-                    <a:bodyPr/>
-                    <a:lstStyle/>
-                    <a:p>
-                      <a:r>
-                        <a:rPr lang="en-US" sz="2800" dirty="0">
+              <a:tr h="521208">
+                <a:tc>
+                  <a:txBody>
+                    <a:bodyPr/>
+                    <a:lstStyle/>
+                    <a:p>
+                      <a:pPr algn="ctr"/>
+                      <a:r>
+                        <a:rPr lang="en-US" sz="2000" dirty="0">
                           <a:solidFill>
                             <a:schemeClr val="tx1"/>
                           </a:solidFill>
@@ -4977,15 +7014,20 @@
                       </a:r>
                     </a:p>
                   </a:txBody>
-                  <a:tcPr/>
-                </a:tc>
-                <a:tc>
-                  <a:txBody>
-                    <a:bodyPr/>
-                    <a:lstStyle/>
-                    <a:p>
-                      <a:r>
-                        <a:rPr lang="en-US" sz="2800" dirty="0">
+                  <a:tcPr anchor="b">
+                    <a:solidFill>
+                      <a:srgbClr val="ED7D31"/>
+                    </a:solidFill>
+                  </a:tcPr>
+                </a:tc>
+                <a:tc>
+                  <a:txBody>
+                    <a:bodyPr/>
+                    <a:lstStyle/>
+                    <a:p>
+                      <a:pPr algn="ctr"/>
+                      <a:r>
+                        <a:rPr lang="en-US" sz="2000" dirty="0">
                           <a:solidFill>
                             <a:schemeClr val="tx1"/>
                           </a:solidFill>
@@ -4994,7 +7036,77 @@
                       </a:r>
                     </a:p>
                   </a:txBody>
-                  <a:tcPr/>
+                  <a:tcPr anchor="b">
+                    <a:solidFill>
+                      <a:srgbClr val="ED7D31"/>
+                    </a:solidFill>
+                  </a:tcPr>
+                </a:tc>
+                <a:tc>
+                  <a:txBody>
+                    <a:bodyPr/>
+                    <a:lstStyle/>
+                    <a:p>
+                      <a:pPr algn="ctr"/>
+                      <a:r>
+                        <a:rPr lang="en-US" sz="2000" dirty="0">
+                          <a:solidFill>
+                            <a:schemeClr val="tx1"/>
+                          </a:solidFill>
+                        </a:rPr>
+                        <a:t>Case-control study?</a:t>
+                      </a:r>
+                    </a:p>
+                  </a:txBody>
+                  <a:tcPr anchor="b">
+                    <a:solidFill>
+                      <a:srgbClr val="ED7D31"/>
+                    </a:solidFill>
+                  </a:tcPr>
+                </a:tc>
+                <a:tc>
+                  <a:txBody>
+                    <a:bodyPr/>
+                    <a:lstStyle/>
+                    <a:p>
+                      <a:pPr algn="ctr"/>
+                      <a:r>
+                        <a:rPr lang="en-US" sz="2000" dirty="0">
+                          <a:solidFill>
+                            <a:schemeClr val="tx1"/>
+                          </a:solidFill>
+                        </a:rPr>
+                        <a:t>Cohort study?</a:t>
+                      </a:r>
+                    </a:p>
+                  </a:txBody>
+                  <a:tcPr anchor="b">
+                    <a:solidFill>
+                      <a:srgbClr val="ED7D31"/>
+                    </a:solidFill>
+                  </a:tcPr>
+                </a:tc>
+                <a:tc>
+                  <a:txBody>
+                    <a:bodyPr/>
+                    <a:lstStyle/>
+                    <a:p>
+                      <a:pPr algn="ctr"/>
+                      <a:r>
+                        <a:rPr lang="en-US" sz="2000" dirty="0">
+                          <a:solidFill>
+                            <a:schemeClr val="tx1"/>
+                          </a:solidFill>
+                        </a:rPr>
+                        <a:t>RCT?</a:t>
+                      </a:r>
+                    </a:p>
+                  </a:txBody>
+                  <a:tcPr anchor="b">
+                    <a:solidFill>
+                      <a:srgbClr val="ED7D31"/>
+                    </a:solidFill>
+                  </a:tcPr>
                 </a:tc>
                 <a:extLst>
                   <a:ext uri="{0D108BD9-81ED-4DB2-BD59-A6C34878D82A}">
@@ -5009,7 +7121,7 @@
                     <a:lstStyle/>
                     <a:p>
                       <a:r>
-                        <a:rPr lang="en-US" sz="2800" dirty="0"/>
+                        <a:rPr lang="en-US" sz="2000" b="1" dirty="0"/>
                         <a:t>Risk difference</a:t>
                       </a:r>
                     </a:p>
@@ -5029,7 +7141,7 @@
                         <a:buChar char="•"/>
                       </a:pPr>
                       <a:r>
-                        <a:rPr lang="en-US" sz="2800" dirty="0"/>
+                        <a:rPr lang="en-US" sz="2000" dirty="0"/>
                         <a:t>Can provide additional information, but can be misleading on its own</a:t>
                       </a:r>
                     </a:p>
@@ -5052,12 +7164,102 @@
                         <a:defRPr/>
                       </a:pPr>
                       <a:r>
+                        <a:rPr lang="en-US" sz="2000" dirty="0"/>
+                        <a:t>Not the preferred measurement </a:t>
+                      </a:r>
+                    </a:p>
+                  </a:txBody>
+                  <a:tcPr/>
+                </a:tc>
+                <a:tc>
+                  <a:txBody>
+                    <a:bodyPr/>
+                    <a:lstStyle/>
+                    <a:p>
+                      <a:pPr marL="0" marR="0" lvl="0" indent="0" algn="ctr" defTabSz="914400" rtl="0" eaLnBrk="1" fontAlgn="auto" latinLnBrk="0" hangingPunct="1">
+                        <a:lnSpc>
+                          <a:spcPct val="114000"/>
+                        </a:lnSpc>
+                        <a:spcBef>
+                          <a:spcPts val="0"/>
+                        </a:spcBef>
+                        <a:spcAft>
+                          <a:spcPts val="0"/>
+                        </a:spcAft>
+                        <a:buClrTx/>
+                        <a:buSzTx/>
+                        <a:buFont typeface="Arial" panose="020B0604020202020204" pitchFamily="34" charset="0"/>
+                        <a:buNone/>
+                        <a:tabLst/>
+                        <a:defRPr/>
+                      </a:pPr>
+                      <a:r>
                         <a:rPr lang="en-US" sz="2800" dirty="0"/>
-                        <a:t>Not the preferred measurement </a:t>
-                      </a:r>
-                    </a:p>
-                  </a:txBody>
-                  <a:tcPr/>
+                        <a:t>🚫</a:t>
+                      </a:r>
+                    </a:p>
+                  </a:txBody>
+                  <a:tcPr anchor="ctr"/>
+                </a:tc>
+                <a:tc>
+                  <a:txBody>
+                    <a:bodyPr/>
+                    <a:lstStyle/>
+                    <a:p>
+                      <a:pPr marL="0" marR="0" lvl="0" indent="0" algn="ctr" defTabSz="914400" rtl="0" eaLnBrk="1" fontAlgn="auto" latinLnBrk="0" hangingPunct="1">
+                        <a:lnSpc>
+                          <a:spcPct val="114000"/>
+                        </a:lnSpc>
+                        <a:spcBef>
+                          <a:spcPts val="0"/>
+                        </a:spcBef>
+                        <a:spcAft>
+                          <a:spcPts val="0"/>
+                        </a:spcAft>
+                        <a:buClrTx/>
+                        <a:buSzTx/>
+                        <a:buFont typeface="Arial" panose="020B0604020202020204" pitchFamily="34" charset="0"/>
+                        <a:buNone/>
+                        <a:tabLst/>
+                        <a:defRPr/>
+                      </a:pPr>
+                      <a:r>
+                        <a:rPr lang="en-US" sz="2800" dirty="0"/>
+                        <a:t>✅</a:t>
+                      </a:r>
+                    </a:p>
+                  </a:txBody>
+                  <a:tcPr anchor="ctr"/>
+                </a:tc>
+                <a:tc>
+                  <a:txBody>
+                    <a:bodyPr/>
+                    <a:lstStyle/>
+                    <a:p>
+                      <a:pPr marL="0" marR="0" lvl="0" indent="0" algn="ctr" defTabSz="914400" rtl="0" eaLnBrk="1" fontAlgn="auto" latinLnBrk="0" hangingPunct="1">
+                        <a:lnSpc>
+                          <a:spcPct val="114000"/>
+                        </a:lnSpc>
+                        <a:spcBef>
+                          <a:spcPts val="0"/>
+                        </a:spcBef>
+                        <a:spcAft>
+                          <a:spcPts val="0"/>
+                        </a:spcAft>
+                        <a:buClrTx/>
+                        <a:buSzTx/>
+                        <a:buFont typeface="Arial" panose="020B0604020202020204" pitchFamily="34" charset="0"/>
+                        <a:buNone/>
+                        <a:tabLst/>
+                        <a:defRPr/>
+                      </a:pPr>
+                      <a:r>
+                        <a:rPr lang="en-US" sz="2800" dirty="0"/>
+                        <a:t>✅</a:t>
+                      </a:r>
+                    </a:p>
+                  </a:txBody>
+                  <a:tcPr anchor="ctr"/>
                 </a:tc>
                 <a:extLst>
                   <a:ext uri="{0D108BD9-81ED-4DB2-BD59-A6C34878D82A}">
@@ -5072,8 +7274,8 @@
                     <a:lstStyle/>
                     <a:p>
                       <a:r>
-                        <a:rPr lang="en-US" sz="2800" dirty="0"/>
-                        <a:t>Risk ratio</a:t>
+                        <a:rPr lang="en-US" sz="2000" b="1" dirty="0"/>
+                        <a:t>Risk ratio / prevalence ratio</a:t>
                       </a:r>
                     </a:p>
                   </a:txBody>
@@ -5092,7 +7294,7 @@
                         <a:buChar char="•"/>
                       </a:pPr>
                       <a:r>
-                        <a:rPr lang="en-US" sz="2800" dirty="0"/>
+                        <a:rPr lang="en-US" sz="2000" dirty="0"/>
                         <a:t>Easy to interpret because is a ratio of probabilities</a:t>
                       </a:r>
                     </a:p>
@@ -5105,12 +7307,102 @@
                         <a:buChar char="•"/>
                       </a:pPr>
                       <a:r>
+                        <a:rPr lang="en-US" sz="2000" dirty="0"/>
+                        <a:t>Cannot use in retrospective, case-control studies</a:t>
+                      </a:r>
+                    </a:p>
+                  </a:txBody>
+                  <a:tcPr/>
+                </a:tc>
+                <a:tc>
+                  <a:txBody>
+                    <a:bodyPr/>
+                    <a:lstStyle/>
+                    <a:p>
+                      <a:pPr marL="0" marR="0" lvl="0" indent="0" algn="ctr" defTabSz="914400" rtl="0" eaLnBrk="1" fontAlgn="auto" latinLnBrk="0" hangingPunct="1">
+                        <a:lnSpc>
+                          <a:spcPct val="114000"/>
+                        </a:lnSpc>
+                        <a:spcBef>
+                          <a:spcPts val="0"/>
+                        </a:spcBef>
+                        <a:spcAft>
+                          <a:spcPts val="0"/>
+                        </a:spcAft>
+                        <a:buClrTx/>
+                        <a:buSzTx/>
+                        <a:buFont typeface="Arial" panose="020B0604020202020204" pitchFamily="34" charset="0"/>
+                        <a:buNone/>
+                        <a:tabLst/>
+                        <a:defRPr/>
+                      </a:pPr>
+                      <a:r>
                         <a:rPr lang="en-US" sz="2800" dirty="0"/>
-                        <a:t>Cannot use in retrospective, case-control studies</a:t>
-                      </a:r>
-                    </a:p>
-                  </a:txBody>
-                  <a:tcPr/>
+                        <a:t>🚫</a:t>
+                      </a:r>
+                    </a:p>
+                  </a:txBody>
+                  <a:tcPr anchor="ctr"/>
+                </a:tc>
+                <a:tc>
+                  <a:txBody>
+                    <a:bodyPr/>
+                    <a:lstStyle/>
+                    <a:p>
+                      <a:pPr marL="0" marR="0" lvl="0" indent="0" algn="ctr" defTabSz="914400" rtl="0" eaLnBrk="1" fontAlgn="auto" latinLnBrk="0" hangingPunct="1">
+                        <a:lnSpc>
+                          <a:spcPct val="114000"/>
+                        </a:lnSpc>
+                        <a:spcBef>
+                          <a:spcPts val="0"/>
+                        </a:spcBef>
+                        <a:spcAft>
+                          <a:spcPts val="0"/>
+                        </a:spcAft>
+                        <a:buClrTx/>
+                        <a:buSzTx/>
+                        <a:buFont typeface="Arial" panose="020B0604020202020204" pitchFamily="34" charset="0"/>
+                        <a:buNone/>
+                        <a:tabLst/>
+                        <a:defRPr/>
+                      </a:pPr>
+                      <a:r>
+                        <a:rPr lang="en-US" sz="2800" dirty="0"/>
+                        <a:t>✅</a:t>
+                      </a:r>
+                    </a:p>
+                  </a:txBody>
+                  <a:tcPr anchor="ctr"/>
+                </a:tc>
+                <a:tc>
+                  <a:txBody>
+                    <a:bodyPr/>
+                    <a:lstStyle/>
+                    <a:p>
+                      <a:pPr marL="0" marR="0" lvl="0" indent="0" algn="ctr" defTabSz="914400" rtl="0" eaLnBrk="1" fontAlgn="auto" latinLnBrk="0" hangingPunct="1">
+                        <a:lnSpc>
+                          <a:spcPct val="114000"/>
+                        </a:lnSpc>
+                        <a:spcBef>
+                          <a:spcPts val="0"/>
+                        </a:spcBef>
+                        <a:spcAft>
+                          <a:spcPts val="0"/>
+                        </a:spcAft>
+                        <a:buClrTx/>
+                        <a:buSzTx/>
+                        <a:buFont typeface="Arial" panose="020B0604020202020204" pitchFamily="34" charset="0"/>
+                        <a:buNone/>
+                        <a:tabLst/>
+                        <a:defRPr/>
+                      </a:pPr>
+                      <a:r>
+                        <a:rPr lang="en-US" sz="2800" dirty="0"/>
+                        <a:t>✅</a:t>
+                      </a:r>
+                    </a:p>
+                  </a:txBody>
+                  <a:tcPr anchor="ctr"/>
                 </a:tc>
                 <a:extLst>
                   <a:ext uri="{0D108BD9-81ED-4DB2-BD59-A6C34878D82A}">
@@ -5125,7 +7417,7 @@
                     <a:lstStyle/>
                     <a:p>
                       <a:r>
-                        <a:rPr lang="en-US" sz="2800" dirty="0"/>
+                        <a:rPr lang="en-US" sz="2000" b="1" dirty="0"/>
                         <a:t>Odds ratio</a:t>
                       </a:r>
                     </a:p>
@@ -5145,8 +7437,21 @@
                         <a:buChar char="•"/>
                       </a:pPr>
                       <a:r>
-                        <a:rPr lang="en-US" sz="2800" dirty="0"/>
-                        <a:t>Adequate for all studies</a:t>
+                        <a:rPr lang="en-US" sz="2000" dirty="0"/>
+                        <a:t>Good estimate of RR for rare diseases</a:t>
+                      </a:r>
+                    </a:p>
+                    <a:p>
+                      <a:pPr marL="742950" lvl="1" indent="-285750">
+                        <a:lnSpc>
+                          <a:spcPct val="114000"/>
+                        </a:lnSpc>
+                        <a:buFont typeface="Arial" panose="020B0604020202020204" pitchFamily="34" charset="0"/>
+                        <a:buChar char="•"/>
+                      </a:pPr>
+                      <a:r>
+                        <a:rPr lang="en-US" sz="2000" dirty="0"/>
+                        <a:t>RR can be calculated for OR regardless of disease rate</a:t>
                       </a:r>
                     </a:p>
                     <a:p>
@@ -5158,8 +7463,8 @@
                         <a:buChar char="•"/>
                       </a:pPr>
                       <a:r>
-                        <a:rPr lang="en-US" sz="2800" dirty="0"/>
-                        <a:t>Good estimate of RR for rare diseases</a:t>
+                        <a:rPr lang="en-US" sz="2000" dirty="0"/>
+                        <a:t>Not as easy to interpret or translate to clinical setting as RR</a:t>
                       </a:r>
                     </a:p>
                     <a:p>
@@ -5171,25 +7476,102 @@
                         <a:buChar char="•"/>
                       </a:pPr>
                       <a:r>
-                        <a:rPr lang="en-US" sz="2800" dirty="0"/>
-                        <a:t>Not as easy to interpret or translate to clinical setting as RR</a:t>
-                      </a:r>
-                    </a:p>
-                    <a:p>
-                      <a:pPr marL="285750" indent="-285750">
+                        <a:rPr lang="en-US" sz="2000" b="1" dirty="0"/>
+                        <a:t>Most preferred by statisticians because integrated into logistic regression</a:t>
+                      </a:r>
+                    </a:p>
+                  </a:txBody>
+                  <a:tcPr/>
+                </a:tc>
+                <a:tc>
+                  <a:txBody>
+                    <a:bodyPr/>
+                    <a:lstStyle/>
+                    <a:p>
+                      <a:pPr marL="0" marR="0" lvl="0" indent="0" algn="ctr" defTabSz="914400" rtl="0" eaLnBrk="1" fontAlgn="auto" latinLnBrk="0" hangingPunct="1">
                         <a:lnSpc>
                           <a:spcPct val="114000"/>
                         </a:lnSpc>
+                        <a:spcBef>
+                          <a:spcPts val="0"/>
+                        </a:spcBef>
+                        <a:spcAft>
+                          <a:spcPts val="0"/>
+                        </a:spcAft>
+                        <a:buClrTx/>
+                        <a:buSzTx/>
                         <a:buFont typeface="Arial" panose="020B0604020202020204" pitchFamily="34" charset="0"/>
-                        <a:buChar char="•"/>
+                        <a:buNone/>
+                        <a:tabLst/>
+                        <a:defRPr/>
                       </a:pPr>
                       <a:r>
-                        <a:rPr lang="en-US" sz="2800" b="1" dirty="0"/>
-                        <a:t>Most preferred by statisticians because integrated into logistic regression</a:t>
-                      </a:r>
-                    </a:p>
-                  </a:txBody>
-                  <a:tcPr/>
+                        <a:rPr lang="en-US" sz="2800" dirty="0"/>
+                        <a:t>✅</a:t>
+                      </a:r>
+                    </a:p>
+                  </a:txBody>
+                  <a:tcPr anchor="ctr"/>
+                </a:tc>
+                <a:tc>
+                  <a:txBody>
+                    <a:bodyPr/>
+                    <a:lstStyle/>
+                    <a:p>
+                      <a:pPr marL="0" marR="0" lvl="0" indent="0" algn="ctr" defTabSz="914400" rtl="0" eaLnBrk="1" fontAlgn="auto" latinLnBrk="0" hangingPunct="1">
+                        <a:lnSpc>
+                          <a:spcPct val="114000"/>
+                        </a:lnSpc>
+                        <a:spcBef>
+                          <a:spcPts val="0"/>
+                        </a:spcBef>
+                        <a:spcAft>
+                          <a:spcPts val="0"/>
+                        </a:spcAft>
+                        <a:buClrTx/>
+                        <a:buSzTx/>
+                        <a:buFont typeface="Arial" panose="020B0604020202020204" pitchFamily="34" charset="0"/>
+                        <a:buNone/>
+                        <a:tabLst/>
+                        <a:defRPr/>
+                      </a:pPr>
+                      <a:r>
+                        <a:rPr lang="en-US" sz="2800" dirty="0"/>
+                        <a:t>✅</a:t>
+                      </a:r>
+                    </a:p>
+                  </a:txBody>
+                  <a:tcPr anchor="ctr"/>
+                </a:tc>
+                <a:tc>
+                  <a:txBody>
+                    <a:bodyPr/>
+                    <a:lstStyle/>
+                    <a:p>
+                      <a:pPr marL="0" marR="0" lvl="0" indent="0" algn="ctr" defTabSz="914400" rtl="0" eaLnBrk="1" fontAlgn="auto" latinLnBrk="0" hangingPunct="1">
+                        <a:lnSpc>
+                          <a:spcPct val="114000"/>
+                        </a:lnSpc>
+                        <a:spcBef>
+                          <a:spcPts val="0"/>
+                        </a:spcBef>
+                        <a:spcAft>
+                          <a:spcPts val="0"/>
+                        </a:spcAft>
+                        <a:buClrTx/>
+                        <a:buSzTx/>
+                        <a:buFont typeface="Arial" panose="020B0604020202020204" pitchFamily="34" charset="0"/>
+                        <a:buNone/>
+                        <a:tabLst/>
+                        <a:defRPr/>
+                      </a:pPr>
+                      <a:r>
+                        <a:rPr lang="en-US" sz="2800" dirty="0"/>
+                        <a:t>✅</a:t>
+                      </a:r>
+                    </a:p>
+                  </a:txBody>
+                  <a:tcPr anchor="ctr"/>
                 </a:tc>
                 <a:extLst>
                   <a:ext uri="{0D108BD9-81ED-4DB2-BD59-A6C34878D82A}">

</xml_diff>